<commit_message>
updates to dataviz lecture
</commit_message>
<xml_diff>
--- a/lectures/0_course_introduction.pptx
+++ b/lectures/0_course_introduction.pptx
@@ -10561,13 +10561,20 @@
             <p:ph type="title"/>
           </p:nvPr>
         </p:nvSpPr>
-        <p:spPr/>
+        <p:spPr>
+          <a:xfrm>
+            <a:off x="528489" y="300447"/>
+            <a:ext cx="10825976" cy="1325563"/>
+          </a:xfrm>
+        </p:spPr>
         <p:txBody>
-          <a:bodyPr/>
+          <a:bodyPr>
+            <a:normAutofit/>
+          </a:bodyPr>
           <a:lstStyle/>
           <a:p>
             <a:r>
-              <a:rPr lang="en-NL" dirty="0"/>
+              <a:rPr lang="en-NL" sz="4000" b="1" dirty="0"/>
               <a:t>You will learn how to answer questions like…</a:t>
             </a:r>
           </a:p>

</xml_diff>

<commit_message>
update timetable and final versions of pitch and course intro
</commit_message>
<xml_diff>
--- a/lectures/0_course_introduction.pptx
+++ b/lectures/0_course_introduction.pptx
@@ -9,9 +9,9 @@
     <p:sldId id="992" r:id="rId3"/>
     <p:sldId id="260" r:id="rId4"/>
     <p:sldId id="258" r:id="rId5"/>
-    <p:sldId id="993" r:id="rId6"/>
-    <p:sldId id="1002" r:id="rId7"/>
-    <p:sldId id="994" r:id="rId8"/>
+    <p:sldId id="1004" r:id="rId6"/>
+    <p:sldId id="1006" r:id="rId7"/>
+    <p:sldId id="1007" r:id="rId8"/>
     <p:sldId id="1000" r:id="rId9"/>
     <p:sldId id="995" r:id="rId10"/>
     <p:sldId id="261" r:id="rId11"/>
@@ -279,7 +279,7 @@
           <a:p>
             <a:fld id="{7315D9CD-A6C7-AE4E-875B-351995A2D2A0}" type="datetimeFigureOut">
               <a:rPr lang="en-NL" smtClean="0"/>
-              <a:t>01/09/2026</a:t>
+              <a:t>02/09/2026</a:t>
             </a:fld>
             <a:endParaRPr lang="en-NL"/>
           </a:p>
@@ -479,7 +479,7 @@
           <a:p>
             <a:fld id="{7315D9CD-A6C7-AE4E-875B-351995A2D2A0}" type="datetimeFigureOut">
               <a:rPr lang="en-NL" smtClean="0"/>
-              <a:t>01/09/2026</a:t>
+              <a:t>02/09/2026</a:t>
             </a:fld>
             <a:endParaRPr lang="en-NL"/>
           </a:p>
@@ -689,7 +689,7 @@
           <a:p>
             <a:fld id="{7315D9CD-A6C7-AE4E-875B-351995A2D2A0}" type="datetimeFigureOut">
               <a:rPr lang="en-NL" smtClean="0"/>
-              <a:t>01/09/2026</a:t>
+              <a:t>02/09/2026</a:t>
             </a:fld>
             <a:endParaRPr lang="en-NL"/>
           </a:p>
@@ -889,7 +889,7 @@
           <a:p>
             <a:fld id="{7315D9CD-A6C7-AE4E-875B-351995A2D2A0}" type="datetimeFigureOut">
               <a:rPr lang="en-NL" smtClean="0"/>
-              <a:t>01/09/2026</a:t>
+              <a:t>02/09/2026</a:t>
             </a:fld>
             <a:endParaRPr lang="en-NL"/>
           </a:p>
@@ -1165,7 +1165,7 @@
           <a:p>
             <a:fld id="{7315D9CD-A6C7-AE4E-875B-351995A2D2A0}" type="datetimeFigureOut">
               <a:rPr lang="en-NL" smtClean="0"/>
-              <a:t>01/09/2026</a:t>
+              <a:t>02/09/2026</a:t>
             </a:fld>
             <a:endParaRPr lang="en-NL"/>
           </a:p>
@@ -1433,7 +1433,7 @@
           <a:p>
             <a:fld id="{7315D9CD-A6C7-AE4E-875B-351995A2D2A0}" type="datetimeFigureOut">
               <a:rPr lang="en-NL" smtClean="0"/>
-              <a:t>01/09/2026</a:t>
+              <a:t>02/09/2026</a:t>
             </a:fld>
             <a:endParaRPr lang="en-NL"/>
           </a:p>
@@ -1848,7 +1848,7 @@
           <a:p>
             <a:fld id="{7315D9CD-A6C7-AE4E-875B-351995A2D2A0}" type="datetimeFigureOut">
               <a:rPr lang="en-NL" smtClean="0"/>
-              <a:t>01/09/2026</a:t>
+              <a:t>02/09/2026</a:t>
             </a:fld>
             <a:endParaRPr lang="en-NL"/>
           </a:p>
@@ -1990,7 +1990,7 @@
           <a:p>
             <a:fld id="{7315D9CD-A6C7-AE4E-875B-351995A2D2A0}" type="datetimeFigureOut">
               <a:rPr lang="en-NL" smtClean="0"/>
-              <a:t>01/09/2026</a:t>
+              <a:t>02/09/2026</a:t>
             </a:fld>
             <a:endParaRPr lang="en-NL"/>
           </a:p>
@@ -2103,7 +2103,7 @@
           <a:p>
             <a:fld id="{7315D9CD-A6C7-AE4E-875B-351995A2D2A0}" type="datetimeFigureOut">
               <a:rPr lang="en-NL" smtClean="0"/>
-              <a:t>01/09/2026</a:t>
+              <a:t>02/09/2026</a:t>
             </a:fld>
             <a:endParaRPr lang="en-NL"/>
           </a:p>
@@ -2416,7 +2416,7 @@
           <a:p>
             <a:fld id="{7315D9CD-A6C7-AE4E-875B-351995A2D2A0}" type="datetimeFigureOut">
               <a:rPr lang="en-NL" smtClean="0"/>
-              <a:t>01/09/2026</a:t>
+              <a:t>02/09/2026</a:t>
             </a:fld>
             <a:endParaRPr lang="en-NL"/>
           </a:p>
@@ -2705,7 +2705,7 @@
           <a:p>
             <a:fld id="{7315D9CD-A6C7-AE4E-875B-351995A2D2A0}" type="datetimeFigureOut">
               <a:rPr lang="en-NL" smtClean="0"/>
-              <a:t>01/09/2026</a:t>
+              <a:t>02/09/2026</a:t>
             </a:fld>
             <a:endParaRPr lang="en-NL"/>
           </a:p>
@@ -2948,7 +2948,7 @@
           <a:p>
             <a:fld id="{7315D9CD-A6C7-AE4E-875B-351995A2D2A0}" type="datetimeFigureOut">
               <a:rPr lang="en-NL" smtClean="0"/>
-              <a:t>01/09/2026</a:t>
+              <a:t>02/09/2026</a:t>
             </a:fld>
             <a:endParaRPr lang="en-NL"/>
           </a:p>
@@ -10177,9 +10177,16 @@
             <p:ph idx="1"/>
           </p:nvPr>
         </p:nvSpPr>
-        <p:spPr/>
+        <p:spPr>
+          <a:xfrm>
+            <a:off x="671861" y="1825625"/>
+            <a:ext cx="10848278" cy="4667250"/>
+          </a:xfrm>
+        </p:spPr>
         <p:txBody>
-          <a:bodyPr/>
+          <a:bodyPr>
+            <a:normAutofit/>
+          </a:bodyPr>
           <a:lstStyle/>
           <a:p>
             <a:pPr>
@@ -10200,7 +10207,7 @@
             </a:pPr>
             <a:r>
               <a:rPr lang="en-NL" dirty="0"/>
-              <a:t>I don’t want to spend time reading, much less providing feedback on, something that nobody wrote</a:t>
+              <a:t>I don’t want to spend time reading, much less providing feedback on, something written by a machine</a:t>
             </a:r>
           </a:p>
           <a:p>
@@ -10215,9 +10222,12 @@
             </a:r>
             <a:r>
               <a:rPr lang="en-NL" i="1" dirty="0"/>
-              <a:t>is the learning process</a:t>
-            </a:r>
-            <a:endParaRPr lang="en-NL" dirty="0"/>
+              <a:t>is the learning process. </a:t>
+            </a:r>
+            <a:r>
+              <a:rPr lang="en-NL" dirty="0"/>
+              <a:t>Don’t bypass this with AI, we have seen examples of this over the last years.</a:t>
+            </a:r>
           </a:p>
         </p:txBody>
       </p:sp>
@@ -12362,7 +12372,7 @@
           <p:cNvPr id="2" name="Title 1">
             <a:extLst>
               <a:ext uri="{FF2B5EF4-FFF2-40B4-BE49-F238E27FC236}">
-                <a16:creationId xmlns:a16="http://schemas.microsoft.com/office/drawing/2014/main" id="{FC16CB94-10D7-D06C-602C-4C44DB0C5A6C}"/>
+                <a16:creationId xmlns:a16="http://schemas.microsoft.com/office/drawing/2014/main" id="{F3ACAF7A-6868-515E-589A-1ADC8B72A154}"/>
               </a:ext>
             </a:extLst>
           </p:cNvPr>
@@ -12378,7 +12388,32 @@
           <a:bodyPr/>
           <a:lstStyle/>
           <a:p>
-            <a:endParaRPr lang="en-NL"/>
+            <a:endParaRPr lang="en-NL" dirty="0"/>
+          </a:p>
+        </p:txBody>
+      </p:sp>
+      <p:sp>
+        <p:nvSpPr>
+          <p:cNvPr id="3" name="Content Placeholder 2">
+            <a:extLst>
+              <a:ext uri="{FF2B5EF4-FFF2-40B4-BE49-F238E27FC236}">
+                <a16:creationId xmlns:a16="http://schemas.microsoft.com/office/drawing/2014/main" id="{97E37E53-9AD3-257A-D033-513A719FB83F}"/>
+              </a:ext>
+            </a:extLst>
+          </p:cNvPr>
+          <p:cNvSpPr>
+            <a:spLocks noGrp="1"/>
+          </p:cNvSpPr>
+          <p:nvPr>
+            <p:ph idx="1"/>
+          </p:nvPr>
+        </p:nvSpPr>
+        <p:spPr/>
+        <p:txBody>
+          <a:bodyPr/>
+          <a:lstStyle/>
+          <a:p>
+            <a:endParaRPr lang="en-NL" dirty="0"/>
           </a:p>
         </p:txBody>
       </p:sp>
@@ -12387,7 +12422,7 @@
           <p:cNvPr id="4" name="Picture 3">
             <a:extLst>
               <a:ext uri="{FF2B5EF4-FFF2-40B4-BE49-F238E27FC236}">
-                <a16:creationId xmlns:a16="http://schemas.microsoft.com/office/drawing/2014/main" id="{8337E3B8-2B2E-21C2-AB44-427881BB4F53}"/>
+                <a16:creationId xmlns:a16="http://schemas.microsoft.com/office/drawing/2014/main" id="{786EACC0-D024-802D-422C-355806E20546}"/>
               </a:ext>
             </a:extLst>
           </p:cNvPr>
@@ -12398,15 +12433,14 @@
         </p:nvPicPr>
         <p:blipFill>
           <a:blip r:embed="rId2"/>
-          <a:srcRect l="9369" t="10412" r="2204"/>
           <a:stretch>
             <a:fillRect/>
           </a:stretch>
         </p:blipFill>
         <p:spPr>
           <a:xfrm>
-            <a:off x="114270" y="277883"/>
-            <a:ext cx="5374362" cy="4377530"/>
+            <a:off x="202990" y="233234"/>
+            <a:ext cx="5801650" cy="4917886"/>
           </a:xfrm>
           <a:prstGeom prst="rect">
             <a:avLst/>
@@ -12418,7 +12452,7 @@
           <p:cNvPr id="5" name="Picture 4">
             <a:extLst>
               <a:ext uri="{FF2B5EF4-FFF2-40B4-BE49-F238E27FC236}">
-                <a16:creationId xmlns:a16="http://schemas.microsoft.com/office/drawing/2014/main" id="{3A2B5370-C34F-5E3A-7757-E5A09118B916}"/>
+                <a16:creationId xmlns:a16="http://schemas.microsoft.com/office/drawing/2014/main" id="{CC43AF36-4051-0648-6B72-F901499B2E96}"/>
               </a:ext>
             </a:extLst>
           </p:cNvPr>
@@ -12429,151 +12463,26 @@
         </p:nvPicPr>
         <p:blipFill>
           <a:blip r:embed="rId3"/>
-          <a:srcRect l="8823" r="3406"/>
           <a:stretch>
             <a:fillRect/>
           </a:stretch>
         </p:blipFill>
         <p:spPr>
           <a:xfrm>
-            <a:off x="5636212" y="2425629"/>
-            <a:ext cx="5374362" cy="4377530"/>
+            <a:off x="6096000" y="1951354"/>
+            <a:ext cx="6045252" cy="4794885"/>
           </a:xfrm>
           <a:prstGeom prst="rect">
             <a:avLst/>
           </a:prstGeom>
         </p:spPr>
       </p:pic>
-      <p:pic>
-        <p:nvPicPr>
-          <p:cNvPr id="23" name="Picture 22">
-            <a:extLst>
-              <a:ext uri="{FF2B5EF4-FFF2-40B4-BE49-F238E27FC236}">
-                <a16:creationId xmlns:a16="http://schemas.microsoft.com/office/drawing/2014/main" id="{9134432B-7AC2-BFEF-5773-36A23682CB4A}"/>
-              </a:ext>
-            </a:extLst>
-          </p:cNvPr>
-          <p:cNvPicPr>
-            <a:picLocks noChangeAspect="1"/>
-          </p:cNvPicPr>
-          <p:nvPr/>
-        </p:nvPicPr>
-        <p:blipFill>
-          <a:blip r:embed="rId4"/>
-          <a:stretch>
-            <a:fillRect/>
-          </a:stretch>
-        </p:blipFill>
-        <p:spPr>
-          <a:xfrm>
-            <a:off x="1656232" y="1922106"/>
-            <a:ext cx="1506894" cy="1506894"/>
-          </a:xfrm>
-          <a:prstGeom prst="ellipse">
-            <a:avLst/>
-          </a:prstGeom>
-        </p:spPr>
-      </p:pic>
-      <p:pic>
-        <p:nvPicPr>
-          <p:cNvPr id="24" name="Picture 23">
-            <a:extLst>
-              <a:ext uri="{FF2B5EF4-FFF2-40B4-BE49-F238E27FC236}">
-                <a16:creationId xmlns:a16="http://schemas.microsoft.com/office/drawing/2014/main" id="{D9815D28-0FFD-9803-25BA-D9EB9F826DD8}"/>
-              </a:ext>
-            </a:extLst>
-          </p:cNvPr>
-          <p:cNvPicPr>
-            <a:picLocks noChangeAspect="1"/>
-          </p:cNvPicPr>
-          <p:nvPr/>
-        </p:nvPicPr>
-        <p:blipFill>
-          <a:blip r:embed="rId5"/>
-          <a:srcRect t="11144" b="7351"/>
-          <a:stretch>
-            <a:fillRect/>
-          </a:stretch>
-        </p:blipFill>
-        <p:spPr>
-          <a:xfrm>
-            <a:off x="3310706" y="1922106"/>
-            <a:ext cx="1504022" cy="1506894"/>
-          </a:xfrm>
-          <a:prstGeom prst="ellipse">
-            <a:avLst/>
-          </a:prstGeom>
-        </p:spPr>
-      </p:pic>
-      <p:pic>
-        <p:nvPicPr>
-          <p:cNvPr id="25" name="Content Placeholder 3" descr="Inaugural lecture by Aalt-Jan van Dijk - SILS - University of Amsterdam">
-            <a:extLst>
-              <a:ext uri="{FF2B5EF4-FFF2-40B4-BE49-F238E27FC236}">
-                <a16:creationId xmlns:a16="http://schemas.microsoft.com/office/drawing/2014/main" id="{5C33ED2E-CEDF-2500-E4EB-AE73A1DAC847}"/>
-              </a:ext>
-            </a:extLst>
-          </p:cNvPr>
-          <p:cNvPicPr>
-            <a:picLocks noGrp="1" noChangeAspect="1"/>
-          </p:cNvPicPr>
-          <p:nvPr>
-            <p:ph idx="1"/>
-          </p:nvPr>
-        </p:nvPicPr>
-        <p:blipFill>
-          <a:blip r:embed="rId6"/>
-          <a:srcRect l="25698" t="5908" r="13797" b="9355"/>
-          <a:stretch>
-            <a:fillRect/>
-          </a:stretch>
-        </p:blipFill>
-        <p:spPr>
-          <a:xfrm>
-            <a:off x="7933764" y="4059424"/>
-            <a:ext cx="1733328" cy="1616057"/>
-          </a:xfrm>
-          <a:prstGeom prst="ellipse">
-            <a:avLst/>
-          </a:prstGeom>
-        </p:spPr>
-      </p:pic>
-      <p:pic>
-        <p:nvPicPr>
-          <p:cNvPr id="3" name="Picture 2">
-            <a:extLst>
-              <a:ext uri="{FF2B5EF4-FFF2-40B4-BE49-F238E27FC236}">
-                <a16:creationId xmlns:a16="http://schemas.microsoft.com/office/drawing/2014/main" id="{B827F3CD-05A2-40E9-136B-3AD5CF7DFB95}"/>
-              </a:ext>
-            </a:extLst>
-          </p:cNvPr>
-          <p:cNvPicPr>
-            <a:picLocks noChangeAspect="1"/>
-          </p:cNvPicPr>
-          <p:nvPr/>
-        </p:nvPicPr>
-        <p:blipFill>
-          <a:blip r:embed="rId7"/>
-          <a:stretch>
-            <a:fillRect/>
-          </a:stretch>
-        </p:blipFill>
-        <p:spPr>
-          <a:xfrm>
-            <a:off x="9906875" y="4002637"/>
-            <a:ext cx="1251279" cy="1729630"/>
-          </a:xfrm>
-          <a:prstGeom prst="ellipse">
-            <a:avLst/>
-          </a:prstGeom>
-        </p:spPr>
-      </p:pic>
       <p:sp>
         <p:nvSpPr>
-          <p:cNvPr id="8" name="Rectangle 7">
-            <a:extLst>
-              <a:ext uri="{FF2B5EF4-FFF2-40B4-BE49-F238E27FC236}">
-                <a16:creationId xmlns:a16="http://schemas.microsoft.com/office/drawing/2014/main" id="{ED543D6A-6EF7-7BFC-8DF3-F9101F94ECA1}"/>
+          <p:cNvPr id="6" name="Rectangle 5">
+            <a:extLst>
+              <a:ext uri="{FF2B5EF4-FFF2-40B4-BE49-F238E27FC236}">
+                <a16:creationId xmlns:a16="http://schemas.microsoft.com/office/drawing/2014/main" id="{0724D6A7-BAB2-F40A-E6B3-219C7B0EB751}"/>
               </a:ext>
             </a:extLst>
           </p:cNvPr>
@@ -12582,7 +12491,7 @@
         </p:nvSpPr>
         <p:spPr>
           <a:xfrm>
-            <a:off x="6786389" y="1922106"/>
+            <a:off x="7385417" y="2071011"/>
             <a:ext cx="4483865" cy="4935894"/>
           </a:xfrm>
           <a:prstGeom prst="rect">
@@ -12624,10 +12533,10 @@
       </p:sp>
       <p:sp>
         <p:nvSpPr>
-          <p:cNvPr id="9" name="Rectangle 8">
-            <a:extLst>
-              <a:ext uri="{FF2B5EF4-FFF2-40B4-BE49-F238E27FC236}">
-                <a16:creationId xmlns:a16="http://schemas.microsoft.com/office/drawing/2014/main" id="{1C4F5FF4-44D7-24EB-B767-4A4E0940F17A}"/>
+          <p:cNvPr id="7" name="Rectangle 6">
+            <a:extLst>
+              <a:ext uri="{FF2B5EF4-FFF2-40B4-BE49-F238E27FC236}">
+                <a16:creationId xmlns:a16="http://schemas.microsoft.com/office/drawing/2014/main" id="{65EC5841-858C-80C1-83ED-90E69B683194}"/>
               </a:ext>
             </a:extLst>
           </p:cNvPr>
@@ -12636,7 +12545,7 @@
         </p:nvSpPr>
         <p:spPr>
           <a:xfrm>
-            <a:off x="5405612" y="4655413"/>
+            <a:off x="6004640" y="4804318"/>
             <a:ext cx="1380778" cy="2147746"/>
           </a:xfrm>
           <a:prstGeom prst="rect">
@@ -12676,416 +12585,71 @@
           </a:p>
         </p:txBody>
       </p:sp>
-      <p:sp>
-        <p:nvSpPr>
-          <p:cNvPr id="10" name="Content Placeholder 2">
-            <a:extLst>
-              <a:ext uri="{FF2B5EF4-FFF2-40B4-BE49-F238E27FC236}">
-                <a16:creationId xmlns:a16="http://schemas.microsoft.com/office/drawing/2014/main" id="{6D090290-1E66-5835-D61D-EEE8205879DA}"/>
-              </a:ext>
-            </a:extLst>
-          </p:cNvPr>
-          <p:cNvSpPr txBox="1">
-            <a:spLocks/>
-          </p:cNvSpPr>
+      <p:pic>
+        <p:nvPicPr>
+          <p:cNvPr id="8" name="Picture 7">
+            <a:extLst>
+              <a:ext uri="{FF2B5EF4-FFF2-40B4-BE49-F238E27FC236}">
+                <a16:creationId xmlns:a16="http://schemas.microsoft.com/office/drawing/2014/main" id="{4BB355F6-AA1F-B14C-505C-69C185176842}"/>
+              </a:ext>
+            </a:extLst>
+          </p:cNvPr>
+          <p:cNvPicPr>
+            <a:picLocks noChangeAspect="1"/>
+          </p:cNvPicPr>
           <p:nvPr/>
-        </p:nvSpPr>
+        </p:nvPicPr>
+        <p:blipFill>
+          <a:blip r:embed="rId4"/>
+          <a:stretch>
+            <a:fillRect/>
+          </a:stretch>
+        </p:blipFill>
         <p:spPr>
           <a:xfrm>
-            <a:off x="165684" y="49965"/>
-            <a:ext cx="1365661" cy="343235"/>
+            <a:off x="2665534" y="2549123"/>
+            <a:ext cx="1506894" cy="1506894"/>
           </a:xfrm>
-          <a:prstGeom prst="rect">
+          <a:prstGeom prst="ellipse">
             <a:avLst/>
           </a:prstGeom>
         </p:spPr>
-        <p:txBody>
-          <a:bodyPr vert="horz" wrap="square" lIns="91440" tIns="45720" rIns="91440" bIns="45720" rtlCol="0">
-            <a:spAutoFit/>
-          </a:bodyPr>
-          <a:lstStyle>
-            <a:lvl1pPr marL="228600" indent="-228600" algn="l" defTabSz="914400" rtl="0" eaLnBrk="1" latinLnBrk="0" hangingPunct="1">
-              <a:lnSpc>
-                <a:spcPct val="90000"/>
-              </a:lnSpc>
-              <a:spcBef>
-                <a:spcPts val="1000"/>
-              </a:spcBef>
-              <a:buFont typeface="Arial" panose="020B0604020202020204" pitchFamily="34" charset="0"/>
-              <a:buChar char="•"/>
-              <a:defRPr sz="2800" kern="1200">
-                <a:solidFill>
-                  <a:schemeClr val="tx1"/>
-                </a:solidFill>
-                <a:latin typeface="+mn-lt"/>
-                <a:ea typeface="+mn-ea"/>
-                <a:cs typeface="+mn-cs"/>
-              </a:defRPr>
-            </a:lvl1pPr>
-            <a:lvl2pPr marL="685800" indent="-228600" algn="l" defTabSz="914400" rtl="0" eaLnBrk="1" latinLnBrk="0" hangingPunct="1">
-              <a:lnSpc>
-                <a:spcPct val="90000"/>
-              </a:lnSpc>
-              <a:spcBef>
-                <a:spcPts val="500"/>
-              </a:spcBef>
-              <a:buFont typeface="Arial" panose="020B0604020202020204" pitchFamily="34" charset="0"/>
-              <a:buChar char="•"/>
-              <a:defRPr sz="2400" kern="1200">
-                <a:solidFill>
-                  <a:schemeClr val="tx1"/>
-                </a:solidFill>
-                <a:latin typeface="+mn-lt"/>
-                <a:ea typeface="+mn-ea"/>
-                <a:cs typeface="+mn-cs"/>
-              </a:defRPr>
-            </a:lvl2pPr>
-            <a:lvl3pPr marL="1143000" indent="-228600" algn="l" defTabSz="914400" rtl="0" eaLnBrk="1" latinLnBrk="0" hangingPunct="1">
-              <a:lnSpc>
-                <a:spcPct val="90000"/>
-              </a:lnSpc>
-              <a:spcBef>
-                <a:spcPts val="500"/>
-              </a:spcBef>
-              <a:buFont typeface="Arial" panose="020B0604020202020204" pitchFamily="34" charset="0"/>
-              <a:buChar char="•"/>
-              <a:defRPr sz="2000" kern="1200">
-                <a:solidFill>
-                  <a:schemeClr val="tx1"/>
-                </a:solidFill>
-                <a:latin typeface="+mn-lt"/>
-                <a:ea typeface="+mn-ea"/>
-                <a:cs typeface="+mn-cs"/>
-              </a:defRPr>
-            </a:lvl3pPr>
-            <a:lvl4pPr marL="1600200" indent="-228600" algn="l" defTabSz="914400" rtl="0" eaLnBrk="1" latinLnBrk="0" hangingPunct="1">
-              <a:lnSpc>
-                <a:spcPct val="90000"/>
-              </a:lnSpc>
-              <a:spcBef>
-                <a:spcPts val="500"/>
-              </a:spcBef>
-              <a:buFont typeface="Arial" panose="020B0604020202020204" pitchFamily="34" charset="0"/>
-              <a:buChar char="•"/>
-              <a:defRPr sz="1800" kern="1200">
-                <a:solidFill>
-                  <a:schemeClr val="tx1"/>
-                </a:solidFill>
-                <a:latin typeface="+mn-lt"/>
-                <a:ea typeface="+mn-ea"/>
-                <a:cs typeface="+mn-cs"/>
-              </a:defRPr>
-            </a:lvl4pPr>
-            <a:lvl5pPr marL="2057400" indent="-228600" algn="l" defTabSz="914400" rtl="0" eaLnBrk="1" latinLnBrk="0" hangingPunct="1">
-              <a:lnSpc>
-                <a:spcPct val="90000"/>
-              </a:lnSpc>
-              <a:spcBef>
-                <a:spcPts val="500"/>
-              </a:spcBef>
-              <a:buFont typeface="Arial" panose="020B0604020202020204" pitchFamily="34" charset="0"/>
-              <a:buChar char="•"/>
-              <a:defRPr sz="1800" kern="1200">
-                <a:solidFill>
-                  <a:schemeClr val="tx1"/>
-                </a:solidFill>
-                <a:latin typeface="+mn-lt"/>
-                <a:ea typeface="+mn-ea"/>
-                <a:cs typeface="+mn-cs"/>
-              </a:defRPr>
-            </a:lvl5pPr>
-            <a:lvl6pPr marL="2514600" indent="-228600" algn="l" defTabSz="914400" rtl="0" eaLnBrk="1" latinLnBrk="0" hangingPunct="1">
-              <a:lnSpc>
-                <a:spcPct val="90000"/>
-              </a:lnSpc>
-              <a:spcBef>
-                <a:spcPts val="500"/>
-              </a:spcBef>
-              <a:buFont typeface="Arial" panose="020B0604020202020204" pitchFamily="34" charset="0"/>
-              <a:buChar char="•"/>
-              <a:defRPr sz="1800" kern="1200">
-                <a:solidFill>
-                  <a:schemeClr val="tx1"/>
-                </a:solidFill>
-                <a:latin typeface="+mn-lt"/>
-                <a:ea typeface="+mn-ea"/>
-                <a:cs typeface="+mn-cs"/>
-              </a:defRPr>
-            </a:lvl6pPr>
-            <a:lvl7pPr marL="2971800" indent="-228600" algn="l" defTabSz="914400" rtl="0" eaLnBrk="1" latinLnBrk="0" hangingPunct="1">
-              <a:lnSpc>
-                <a:spcPct val="90000"/>
-              </a:lnSpc>
-              <a:spcBef>
-                <a:spcPts val="500"/>
-              </a:spcBef>
-              <a:buFont typeface="Arial" panose="020B0604020202020204" pitchFamily="34" charset="0"/>
-              <a:buChar char="•"/>
-              <a:defRPr sz="1800" kern="1200">
-                <a:solidFill>
-                  <a:schemeClr val="tx1"/>
-                </a:solidFill>
-                <a:latin typeface="+mn-lt"/>
-                <a:ea typeface="+mn-ea"/>
-                <a:cs typeface="+mn-cs"/>
-              </a:defRPr>
-            </a:lvl7pPr>
-            <a:lvl8pPr marL="3429000" indent="-228600" algn="l" defTabSz="914400" rtl="0" eaLnBrk="1" latinLnBrk="0" hangingPunct="1">
-              <a:lnSpc>
-                <a:spcPct val="90000"/>
-              </a:lnSpc>
-              <a:spcBef>
-                <a:spcPts val="500"/>
-              </a:spcBef>
-              <a:buFont typeface="Arial" panose="020B0604020202020204" pitchFamily="34" charset="0"/>
-              <a:buChar char="•"/>
-              <a:defRPr sz="1800" kern="1200">
-                <a:solidFill>
-                  <a:schemeClr val="tx1"/>
-                </a:solidFill>
-                <a:latin typeface="+mn-lt"/>
-                <a:ea typeface="+mn-ea"/>
-                <a:cs typeface="+mn-cs"/>
-              </a:defRPr>
-            </a:lvl8pPr>
-            <a:lvl9pPr marL="3886200" indent="-228600" algn="l" defTabSz="914400" rtl="0" eaLnBrk="1" latinLnBrk="0" hangingPunct="1">
-              <a:lnSpc>
-                <a:spcPct val="90000"/>
-              </a:lnSpc>
-              <a:spcBef>
-                <a:spcPts val="500"/>
-              </a:spcBef>
-              <a:buFont typeface="Arial" panose="020B0604020202020204" pitchFamily="34" charset="0"/>
-              <a:buChar char="•"/>
-              <a:defRPr sz="1800" kern="1200">
-                <a:solidFill>
-                  <a:schemeClr val="tx1"/>
-                </a:solidFill>
-                <a:latin typeface="+mn-lt"/>
-                <a:ea typeface="+mn-ea"/>
-                <a:cs typeface="+mn-cs"/>
-              </a:defRPr>
-            </a:lvl9pPr>
-          </a:lstStyle>
-          <a:p>
-            <a:pPr marL="0" indent="0">
-              <a:buNone/>
-            </a:pPr>
-            <a:r>
-              <a:rPr lang="en-NL" sz="1800" b="1" dirty="0"/>
-              <a:t>September</a:t>
-            </a:r>
-            <a:endParaRPr lang="en-NL" sz="1800" i="1" dirty="0"/>
-          </a:p>
-        </p:txBody>
-      </p:sp>
-      <p:sp>
-        <p:nvSpPr>
-          <p:cNvPr id="11" name="Content Placeholder 2">
-            <a:extLst>
-              <a:ext uri="{FF2B5EF4-FFF2-40B4-BE49-F238E27FC236}">
-                <a16:creationId xmlns:a16="http://schemas.microsoft.com/office/drawing/2014/main" id="{52F9C452-C2C6-ECF3-938F-941CC5FCACA0}"/>
-              </a:ext>
-            </a:extLst>
-          </p:cNvPr>
-          <p:cNvSpPr txBox="1">
-            <a:spLocks/>
-          </p:cNvSpPr>
+      </p:pic>
+      <p:pic>
+        <p:nvPicPr>
+          <p:cNvPr id="9" name="Picture 8">
+            <a:extLst>
+              <a:ext uri="{FF2B5EF4-FFF2-40B4-BE49-F238E27FC236}">
+                <a16:creationId xmlns:a16="http://schemas.microsoft.com/office/drawing/2014/main" id="{F2279A98-3354-ABA8-47FE-597BAF792934}"/>
+              </a:ext>
+            </a:extLst>
+          </p:cNvPr>
+          <p:cNvPicPr>
+            <a:picLocks noChangeAspect="1"/>
+          </p:cNvPicPr>
           <p:nvPr/>
-        </p:nvSpPr>
+        </p:nvPicPr>
+        <p:blipFill>
+          <a:blip r:embed="rId5"/>
+          <a:srcRect t="11144" b="7351"/>
+          <a:stretch>
+            <a:fillRect/>
+          </a:stretch>
+        </p:blipFill>
         <p:spPr>
           <a:xfrm>
-            <a:off x="3163126" y="21890"/>
-            <a:ext cx="1365661" cy="343235"/>
+            <a:off x="4320008" y="2549123"/>
+            <a:ext cx="1504022" cy="1506894"/>
           </a:xfrm>
-          <a:prstGeom prst="rect">
+          <a:prstGeom prst="ellipse">
             <a:avLst/>
           </a:prstGeom>
         </p:spPr>
-        <p:txBody>
-          <a:bodyPr vert="horz" wrap="square" lIns="91440" tIns="45720" rIns="91440" bIns="45720" rtlCol="0">
-            <a:spAutoFit/>
-          </a:bodyPr>
-          <a:lstStyle>
-            <a:lvl1pPr marL="228600" indent="-228600" algn="l" defTabSz="914400" rtl="0" eaLnBrk="1" latinLnBrk="0" hangingPunct="1">
-              <a:lnSpc>
-                <a:spcPct val="90000"/>
-              </a:lnSpc>
-              <a:spcBef>
-                <a:spcPts val="1000"/>
-              </a:spcBef>
-              <a:buFont typeface="Arial" panose="020B0604020202020204" pitchFamily="34" charset="0"/>
-              <a:buChar char="•"/>
-              <a:defRPr sz="2800" kern="1200">
-                <a:solidFill>
-                  <a:schemeClr val="tx1"/>
-                </a:solidFill>
-                <a:latin typeface="+mn-lt"/>
-                <a:ea typeface="+mn-ea"/>
-                <a:cs typeface="+mn-cs"/>
-              </a:defRPr>
-            </a:lvl1pPr>
-            <a:lvl2pPr marL="685800" indent="-228600" algn="l" defTabSz="914400" rtl="0" eaLnBrk="1" latinLnBrk="0" hangingPunct="1">
-              <a:lnSpc>
-                <a:spcPct val="90000"/>
-              </a:lnSpc>
-              <a:spcBef>
-                <a:spcPts val="500"/>
-              </a:spcBef>
-              <a:buFont typeface="Arial" panose="020B0604020202020204" pitchFamily="34" charset="0"/>
-              <a:buChar char="•"/>
-              <a:defRPr sz="2400" kern="1200">
-                <a:solidFill>
-                  <a:schemeClr val="tx1"/>
-                </a:solidFill>
-                <a:latin typeface="+mn-lt"/>
-                <a:ea typeface="+mn-ea"/>
-                <a:cs typeface="+mn-cs"/>
-              </a:defRPr>
-            </a:lvl2pPr>
-            <a:lvl3pPr marL="1143000" indent="-228600" algn="l" defTabSz="914400" rtl="0" eaLnBrk="1" latinLnBrk="0" hangingPunct="1">
-              <a:lnSpc>
-                <a:spcPct val="90000"/>
-              </a:lnSpc>
-              <a:spcBef>
-                <a:spcPts val="500"/>
-              </a:spcBef>
-              <a:buFont typeface="Arial" panose="020B0604020202020204" pitchFamily="34" charset="0"/>
-              <a:buChar char="•"/>
-              <a:defRPr sz="2000" kern="1200">
-                <a:solidFill>
-                  <a:schemeClr val="tx1"/>
-                </a:solidFill>
-                <a:latin typeface="+mn-lt"/>
-                <a:ea typeface="+mn-ea"/>
-                <a:cs typeface="+mn-cs"/>
-              </a:defRPr>
-            </a:lvl3pPr>
-            <a:lvl4pPr marL="1600200" indent="-228600" algn="l" defTabSz="914400" rtl="0" eaLnBrk="1" latinLnBrk="0" hangingPunct="1">
-              <a:lnSpc>
-                <a:spcPct val="90000"/>
-              </a:lnSpc>
-              <a:spcBef>
-                <a:spcPts val="500"/>
-              </a:spcBef>
-              <a:buFont typeface="Arial" panose="020B0604020202020204" pitchFamily="34" charset="0"/>
-              <a:buChar char="•"/>
-              <a:defRPr sz="1800" kern="1200">
-                <a:solidFill>
-                  <a:schemeClr val="tx1"/>
-                </a:solidFill>
-                <a:latin typeface="+mn-lt"/>
-                <a:ea typeface="+mn-ea"/>
-                <a:cs typeface="+mn-cs"/>
-              </a:defRPr>
-            </a:lvl4pPr>
-            <a:lvl5pPr marL="2057400" indent="-228600" algn="l" defTabSz="914400" rtl="0" eaLnBrk="1" latinLnBrk="0" hangingPunct="1">
-              <a:lnSpc>
-                <a:spcPct val="90000"/>
-              </a:lnSpc>
-              <a:spcBef>
-                <a:spcPts val="500"/>
-              </a:spcBef>
-              <a:buFont typeface="Arial" panose="020B0604020202020204" pitchFamily="34" charset="0"/>
-              <a:buChar char="•"/>
-              <a:defRPr sz="1800" kern="1200">
-                <a:solidFill>
-                  <a:schemeClr val="tx1"/>
-                </a:solidFill>
-                <a:latin typeface="+mn-lt"/>
-                <a:ea typeface="+mn-ea"/>
-                <a:cs typeface="+mn-cs"/>
-              </a:defRPr>
-            </a:lvl5pPr>
-            <a:lvl6pPr marL="2514600" indent="-228600" algn="l" defTabSz="914400" rtl="0" eaLnBrk="1" latinLnBrk="0" hangingPunct="1">
-              <a:lnSpc>
-                <a:spcPct val="90000"/>
-              </a:lnSpc>
-              <a:spcBef>
-                <a:spcPts val="500"/>
-              </a:spcBef>
-              <a:buFont typeface="Arial" panose="020B0604020202020204" pitchFamily="34" charset="0"/>
-              <a:buChar char="•"/>
-              <a:defRPr sz="1800" kern="1200">
-                <a:solidFill>
-                  <a:schemeClr val="tx1"/>
-                </a:solidFill>
-                <a:latin typeface="+mn-lt"/>
-                <a:ea typeface="+mn-ea"/>
-                <a:cs typeface="+mn-cs"/>
-              </a:defRPr>
-            </a:lvl6pPr>
-            <a:lvl7pPr marL="2971800" indent="-228600" algn="l" defTabSz="914400" rtl="0" eaLnBrk="1" latinLnBrk="0" hangingPunct="1">
-              <a:lnSpc>
-                <a:spcPct val="90000"/>
-              </a:lnSpc>
-              <a:spcBef>
-                <a:spcPts val="500"/>
-              </a:spcBef>
-              <a:buFont typeface="Arial" panose="020B0604020202020204" pitchFamily="34" charset="0"/>
-              <a:buChar char="•"/>
-              <a:defRPr sz="1800" kern="1200">
-                <a:solidFill>
-                  <a:schemeClr val="tx1"/>
-                </a:solidFill>
-                <a:latin typeface="+mn-lt"/>
-                <a:ea typeface="+mn-ea"/>
-                <a:cs typeface="+mn-cs"/>
-              </a:defRPr>
-            </a:lvl7pPr>
-            <a:lvl8pPr marL="3429000" indent="-228600" algn="l" defTabSz="914400" rtl="0" eaLnBrk="1" latinLnBrk="0" hangingPunct="1">
-              <a:lnSpc>
-                <a:spcPct val="90000"/>
-              </a:lnSpc>
-              <a:spcBef>
-                <a:spcPts val="500"/>
-              </a:spcBef>
-              <a:buFont typeface="Arial" panose="020B0604020202020204" pitchFamily="34" charset="0"/>
-              <a:buChar char="•"/>
-              <a:defRPr sz="1800" kern="1200">
-                <a:solidFill>
-                  <a:schemeClr val="tx1"/>
-                </a:solidFill>
-                <a:latin typeface="+mn-lt"/>
-                <a:ea typeface="+mn-ea"/>
-                <a:cs typeface="+mn-cs"/>
-              </a:defRPr>
-            </a:lvl8pPr>
-            <a:lvl9pPr marL="3886200" indent="-228600" algn="l" defTabSz="914400" rtl="0" eaLnBrk="1" latinLnBrk="0" hangingPunct="1">
-              <a:lnSpc>
-                <a:spcPct val="90000"/>
-              </a:lnSpc>
-              <a:spcBef>
-                <a:spcPts val="500"/>
-              </a:spcBef>
-              <a:buFont typeface="Arial" panose="020B0604020202020204" pitchFamily="34" charset="0"/>
-              <a:buChar char="•"/>
-              <a:defRPr sz="1800" kern="1200">
-                <a:solidFill>
-                  <a:schemeClr val="tx1"/>
-                </a:solidFill>
-                <a:latin typeface="+mn-lt"/>
-                <a:ea typeface="+mn-ea"/>
-                <a:cs typeface="+mn-cs"/>
-              </a:defRPr>
-            </a:lvl9pPr>
-          </a:lstStyle>
-          <a:p>
-            <a:pPr marL="0" indent="0">
-              <a:buNone/>
-            </a:pPr>
-            <a:r>
-              <a:rPr lang="en-NL" sz="1800" b="1" dirty="0"/>
-              <a:t>October</a:t>
-            </a:r>
-            <a:endParaRPr lang="en-NL" sz="1800" i="1" dirty="0"/>
-          </a:p>
-        </p:txBody>
-      </p:sp>
+      </p:pic>
     </p:spTree>
     <p:extLst>
       <p:ext uri="{BB962C8B-B14F-4D97-AF65-F5344CB8AC3E}">
-        <p14:creationId xmlns:p14="http://schemas.microsoft.com/office/powerpoint/2010/main" val="2180767079"/>
+        <p14:creationId xmlns:p14="http://schemas.microsoft.com/office/powerpoint/2010/main" val="1278221828"/>
       </p:ext>
     </p:extLst>
   </p:cSld>
@@ -13103,7 +12667,7 @@
         <p:cNvPr id="1" name="">
           <a:extLst>
             <a:ext uri="{FF2B5EF4-FFF2-40B4-BE49-F238E27FC236}">
-              <a16:creationId xmlns:a16="http://schemas.microsoft.com/office/drawing/2014/main" id="{240A137B-39E5-DED0-3A9F-E1B6AFE895D2}"/>
+              <a16:creationId xmlns:a16="http://schemas.microsoft.com/office/drawing/2014/main" id="{A5FDDDDE-F91B-6144-4672-09FD94A5B78B}"/>
             </a:ext>
           </a:extLst>
         </p:cNvPr>
@@ -13123,7 +12687,7 @@
           <p:cNvPr id="2" name="Title 1">
             <a:extLst>
               <a:ext uri="{FF2B5EF4-FFF2-40B4-BE49-F238E27FC236}">
-                <a16:creationId xmlns:a16="http://schemas.microsoft.com/office/drawing/2014/main" id="{ADE22434-B4F0-807B-2992-40FF15C9EC40}"/>
+                <a16:creationId xmlns:a16="http://schemas.microsoft.com/office/drawing/2014/main" id="{8A58E065-21B4-7F9E-90BE-3D653094BDDB}"/>
               </a:ext>
             </a:extLst>
           </p:cNvPr>
@@ -13143,12 +12707,37 @@
           </a:p>
         </p:txBody>
       </p:sp>
+      <p:sp>
+        <p:nvSpPr>
+          <p:cNvPr id="3" name="Content Placeholder 2">
+            <a:extLst>
+              <a:ext uri="{FF2B5EF4-FFF2-40B4-BE49-F238E27FC236}">
+                <a16:creationId xmlns:a16="http://schemas.microsoft.com/office/drawing/2014/main" id="{89B10A0C-0808-34FC-BF23-582621844D26}"/>
+              </a:ext>
+            </a:extLst>
+          </p:cNvPr>
+          <p:cNvSpPr>
+            <a:spLocks noGrp="1"/>
+          </p:cNvSpPr>
+          <p:nvPr>
+            <p:ph idx="1"/>
+          </p:nvPr>
+        </p:nvSpPr>
+        <p:spPr/>
+        <p:txBody>
+          <a:bodyPr/>
+          <a:lstStyle/>
+          <a:p>
+            <a:endParaRPr lang="en-NL" dirty="0"/>
+          </a:p>
+        </p:txBody>
+      </p:sp>
       <p:pic>
         <p:nvPicPr>
           <p:cNvPr id="4" name="Picture 3">
             <a:extLst>
               <a:ext uri="{FF2B5EF4-FFF2-40B4-BE49-F238E27FC236}">
-                <a16:creationId xmlns:a16="http://schemas.microsoft.com/office/drawing/2014/main" id="{CE91B40A-4EAD-E2B6-C450-A18AE0491CC6}"/>
+                <a16:creationId xmlns:a16="http://schemas.microsoft.com/office/drawing/2014/main" id="{C2772223-93DF-FBE2-809E-092A4CD8680F}"/>
               </a:ext>
             </a:extLst>
           </p:cNvPr>
@@ -13159,15 +12748,14 @@
         </p:nvPicPr>
         <p:blipFill>
           <a:blip r:embed="rId2"/>
-          <a:srcRect l="9369" t="10412" r="2204"/>
           <a:stretch>
             <a:fillRect/>
           </a:stretch>
         </p:blipFill>
         <p:spPr>
           <a:xfrm>
-            <a:off x="114270" y="277883"/>
-            <a:ext cx="5374362" cy="4377530"/>
+            <a:off x="202990" y="233234"/>
+            <a:ext cx="5801650" cy="4917886"/>
           </a:xfrm>
           <a:prstGeom prst="rect">
             <a:avLst/>
@@ -13179,7 +12767,7 @@
           <p:cNvPr id="5" name="Picture 4">
             <a:extLst>
               <a:ext uri="{FF2B5EF4-FFF2-40B4-BE49-F238E27FC236}">
-                <a16:creationId xmlns:a16="http://schemas.microsoft.com/office/drawing/2014/main" id="{0A26C738-1B54-27C0-7A63-34BA65C114B7}"/>
+                <a16:creationId xmlns:a16="http://schemas.microsoft.com/office/drawing/2014/main" id="{58FC5982-73EC-4C19-B56F-2B322038B960}"/>
               </a:ext>
             </a:extLst>
           </p:cNvPr>
@@ -13190,141 +12778,16 @@
         </p:nvPicPr>
         <p:blipFill>
           <a:blip r:embed="rId3"/>
-          <a:srcRect l="8823" r="3406"/>
           <a:stretch>
             <a:fillRect/>
           </a:stretch>
         </p:blipFill>
         <p:spPr>
           <a:xfrm>
-            <a:off x="5636212" y="2425629"/>
-            <a:ext cx="5374362" cy="4377530"/>
+            <a:off x="6096000" y="1951354"/>
+            <a:ext cx="6045252" cy="4794885"/>
           </a:xfrm>
           <a:prstGeom prst="rect">
-            <a:avLst/>
-          </a:prstGeom>
-        </p:spPr>
-      </p:pic>
-      <p:pic>
-        <p:nvPicPr>
-          <p:cNvPr id="23" name="Picture 22">
-            <a:extLst>
-              <a:ext uri="{FF2B5EF4-FFF2-40B4-BE49-F238E27FC236}">
-                <a16:creationId xmlns:a16="http://schemas.microsoft.com/office/drawing/2014/main" id="{0AFE9195-1127-3ACB-418F-97999364D4EA}"/>
-              </a:ext>
-            </a:extLst>
-          </p:cNvPr>
-          <p:cNvPicPr>
-            <a:picLocks noChangeAspect="1"/>
-          </p:cNvPicPr>
-          <p:nvPr/>
-        </p:nvPicPr>
-        <p:blipFill>
-          <a:blip r:embed="rId4"/>
-          <a:stretch>
-            <a:fillRect/>
-          </a:stretch>
-        </p:blipFill>
-        <p:spPr>
-          <a:xfrm>
-            <a:off x="1656232" y="1922106"/>
-            <a:ext cx="1506894" cy="1506894"/>
-          </a:xfrm>
-          <a:prstGeom prst="ellipse">
-            <a:avLst/>
-          </a:prstGeom>
-        </p:spPr>
-      </p:pic>
-      <p:pic>
-        <p:nvPicPr>
-          <p:cNvPr id="24" name="Picture 23">
-            <a:extLst>
-              <a:ext uri="{FF2B5EF4-FFF2-40B4-BE49-F238E27FC236}">
-                <a16:creationId xmlns:a16="http://schemas.microsoft.com/office/drawing/2014/main" id="{3BF2A400-E43E-0910-92CE-39A2AEC7D714}"/>
-              </a:ext>
-            </a:extLst>
-          </p:cNvPr>
-          <p:cNvPicPr>
-            <a:picLocks noChangeAspect="1"/>
-          </p:cNvPicPr>
-          <p:nvPr/>
-        </p:nvPicPr>
-        <p:blipFill>
-          <a:blip r:embed="rId5"/>
-          <a:srcRect t="11144" b="7351"/>
-          <a:stretch>
-            <a:fillRect/>
-          </a:stretch>
-        </p:blipFill>
-        <p:spPr>
-          <a:xfrm>
-            <a:off x="3310706" y="1922106"/>
-            <a:ext cx="1504022" cy="1506894"/>
-          </a:xfrm>
-          <a:prstGeom prst="ellipse">
-            <a:avLst/>
-          </a:prstGeom>
-        </p:spPr>
-      </p:pic>
-      <p:pic>
-        <p:nvPicPr>
-          <p:cNvPr id="25" name="Content Placeholder 3" descr="Inaugural lecture by Aalt-Jan van Dijk - SILS - University of Amsterdam">
-            <a:extLst>
-              <a:ext uri="{FF2B5EF4-FFF2-40B4-BE49-F238E27FC236}">
-                <a16:creationId xmlns:a16="http://schemas.microsoft.com/office/drawing/2014/main" id="{FA6D77D0-FDBF-DEC2-DD3A-8DDEC7872F71}"/>
-              </a:ext>
-            </a:extLst>
-          </p:cNvPr>
-          <p:cNvPicPr>
-            <a:picLocks noGrp="1" noChangeAspect="1"/>
-          </p:cNvPicPr>
-          <p:nvPr>
-            <p:ph idx="1"/>
-          </p:nvPr>
-        </p:nvPicPr>
-        <p:blipFill>
-          <a:blip r:embed="rId6"/>
-          <a:srcRect l="25698" t="5908" r="13797" b="9355"/>
-          <a:stretch>
-            <a:fillRect/>
-          </a:stretch>
-        </p:blipFill>
-        <p:spPr>
-          <a:xfrm>
-            <a:off x="7933764" y="4059424"/>
-            <a:ext cx="1733328" cy="1616057"/>
-          </a:xfrm>
-          <a:prstGeom prst="ellipse">
-            <a:avLst/>
-          </a:prstGeom>
-        </p:spPr>
-      </p:pic>
-      <p:pic>
-        <p:nvPicPr>
-          <p:cNvPr id="3" name="Picture 2">
-            <a:extLst>
-              <a:ext uri="{FF2B5EF4-FFF2-40B4-BE49-F238E27FC236}">
-                <a16:creationId xmlns:a16="http://schemas.microsoft.com/office/drawing/2014/main" id="{79646070-3661-EA8C-F813-AEBEFE2EEEE5}"/>
-              </a:ext>
-            </a:extLst>
-          </p:cNvPr>
-          <p:cNvPicPr>
-            <a:picLocks noChangeAspect="1"/>
-          </p:cNvPicPr>
-          <p:nvPr/>
-        </p:nvPicPr>
-        <p:blipFill>
-          <a:blip r:embed="rId7"/>
-          <a:stretch>
-            <a:fillRect/>
-          </a:stretch>
-        </p:blipFill>
-        <p:spPr>
-          <a:xfrm>
-            <a:off x="9906875" y="4002637"/>
-            <a:ext cx="1251279" cy="1729630"/>
-          </a:xfrm>
-          <a:prstGeom prst="ellipse">
             <a:avLst/>
           </a:prstGeom>
         </p:spPr>
@@ -13334,7 +12797,7 @@
           <p:cNvPr id="6" name="Rectangle 5">
             <a:extLst>
               <a:ext uri="{FF2B5EF4-FFF2-40B4-BE49-F238E27FC236}">
-                <a16:creationId xmlns:a16="http://schemas.microsoft.com/office/drawing/2014/main" id="{E674B0AD-73A2-7C55-32FD-B10284A6FB32}"/>
+                <a16:creationId xmlns:a16="http://schemas.microsoft.com/office/drawing/2014/main" id="{D6077AEB-10F1-B076-F31F-33F9BBD46A35}"/>
               </a:ext>
             </a:extLst>
           </p:cNvPr>
@@ -13343,8 +12806,8 @@
         </p:nvSpPr>
         <p:spPr>
           <a:xfrm>
-            <a:off x="114270" y="365125"/>
-            <a:ext cx="5521942" cy="4935894"/>
+            <a:off x="0" y="306484"/>
+            <a:ext cx="5930537" cy="4935894"/>
           </a:xfrm>
           <a:prstGeom prst="rect">
             <a:avLst/>
@@ -13385,416 +12848,10 @@
       </p:sp>
       <p:sp>
         <p:nvSpPr>
-          <p:cNvPr id="7" name="Content Placeholder 2">
-            <a:extLst>
-              <a:ext uri="{FF2B5EF4-FFF2-40B4-BE49-F238E27FC236}">
-                <a16:creationId xmlns:a16="http://schemas.microsoft.com/office/drawing/2014/main" id="{4E671090-73BB-9388-995C-B8B575B86EC5}"/>
-              </a:ext>
-            </a:extLst>
-          </p:cNvPr>
-          <p:cNvSpPr txBox="1">
-            <a:spLocks/>
-          </p:cNvSpPr>
-          <p:nvPr/>
-        </p:nvSpPr>
-        <p:spPr>
-          <a:xfrm>
-            <a:off x="165684" y="49965"/>
-            <a:ext cx="1365661" cy="343235"/>
-          </a:xfrm>
-          <a:prstGeom prst="rect">
-            <a:avLst/>
-          </a:prstGeom>
-        </p:spPr>
-        <p:txBody>
-          <a:bodyPr vert="horz" wrap="square" lIns="91440" tIns="45720" rIns="91440" bIns="45720" rtlCol="0">
-            <a:spAutoFit/>
-          </a:bodyPr>
-          <a:lstStyle>
-            <a:lvl1pPr marL="228600" indent="-228600" algn="l" defTabSz="914400" rtl="0" eaLnBrk="1" latinLnBrk="0" hangingPunct="1">
-              <a:lnSpc>
-                <a:spcPct val="90000"/>
-              </a:lnSpc>
-              <a:spcBef>
-                <a:spcPts val="1000"/>
-              </a:spcBef>
-              <a:buFont typeface="Arial" panose="020B0604020202020204" pitchFamily="34" charset="0"/>
-              <a:buChar char="•"/>
-              <a:defRPr sz="2800" kern="1200">
-                <a:solidFill>
-                  <a:schemeClr val="tx1"/>
-                </a:solidFill>
-                <a:latin typeface="+mn-lt"/>
-                <a:ea typeface="+mn-ea"/>
-                <a:cs typeface="+mn-cs"/>
-              </a:defRPr>
-            </a:lvl1pPr>
-            <a:lvl2pPr marL="685800" indent="-228600" algn="l" defTabSz="914400" rtl="0" eaLnBrk="1" latinLnBrk="0" hangingPunct="1">
-              <a:lnSpc>
-                <a:spcPct val="90000"/>
-              </a:lnSpc>
-              <a:spcBef>
-                <a:spcPts val="500"/>
-              </a:spcBef>
-              <a:buFont typeface="Arial" panose="020B0604020202020204" pitchFamily="34" charset="0"/>
-              <a:buChar char="•"/>
-              <a:defRPr sz="2400" kern="1200">
-                <a:solidFill>
-                  <a:schemeClr val="tx1"/>
-                </a:solidFill>
-                <a:latin typeface="+mn-lt"/>
-                <a:ea typeface="+mn-ea"/>
-                <a:cs typeface="+mn-cs"/>
-              </a:defRPr>
-            </a:lvl2pPr>
-            <a:lvl3pPr marL="1143000" indent="-228600" algn="l" defTabSz="914400" rtl="0" eaLnBrk="1" latinLnBrk="0" hangingPunct="1">
-              <a:lnSpc>
-                <a:spcPct val="90000"/>
-              </a:lnSpc>
-              <a:spcBef>
-                <a:spcPts val="500"/>
-              </a:spcBef>
-              <a:buFont typeface="Arial" panose="020B0604020202020204" pitchFamily="34" charset="0"/>
-              <a:buChar char="•"/>
-              <a:defRPr sz="2000" kern="1200">
-                <a:solidFill>
-                  <a:schemeClr val="tx1"/>
-                </a:solidFill>
-                <a:latin typeface="+mn-lt"/>
-                <a:ea typeface="+mn-ea"/>
-                <a:cs typeface="+mn-cs"/>
-              </a:defRPr>
-            </a:lvl3pPr>
-            <a:lvl4pPr marL="1600200" indent="-228600" algn="l" defTabSz="914400" rtl="0" eaLnBrk="1" latinLnBrk="0" hangingPunct="1">
-              <a:lnSpc>
-                <a:spcPct val="90000"/>
-              </a:lnSpc>
-              <a:spcBef>
-                <a:spcPts val="500"/>
-              </a:spcBef>
-              <a:buFont typeface="Arial" panose="020B0604020202020204" pitchFamily="34" charset="0"/>
-              <a:buChar char="•"/>
-              <a:defRPr sz="1800" kern="1200">
-                <a:solidFill>
-                  <a:schemeClr val="tx1"/>
-                </a:solidFill>
-                <a:latin typeface="+mn-lt"/>
-                <a:ea typeface="+mn-ea"/>
-                <a:cs typeface="+mn-cs"/>
-              </a:defRPr>
-            </a:lvl4pPr>
-            <a:lvl5pPr marL="2057400" indent="-228600" algn="l" defTabSz="914400" rtl="0" eaLnBrk="1" latinLnBrk="0" hangingPunct="1">
-              <a:lnSpc>
-                <a:spcPct val="90000"/>
-              </a:lnSpc>
-              <a:spcBef>
-                <a:spcPts val="500"/>
-              </a:spcBef>
-              <a:buFont typeface="Arial" panose="020B0604020202020204" pitchFamily="34" charset="0"/>
-              <a:buChar char="•"/>
-              <a:defRPr sz="1800" kern="1200">
-                <a:solidFill>
-                  <a:schemeClr val="tx1"/>
-                </a:solidFill>
-                <a:latin typeface="+mn-lt"/>
-                <a:ea typeface="+mn-ea"/>
-                <a:cs typeface="+mn-cs"/>
-              </a:defRPr>
-            </a:lvl5pPr>
-            <a:lvl6pPr marL="2514600" indent="-228600" algn="l" defTabSz="914400" rtl="0" eaLnBrk="1" latinLnBrk="0" hangingPunct="1">
-              <a:lnSpc>
-                <a:spcPct val="90000"/>
-              </a:lnSpc>
-              <a:spcBef>
-                <a:spcPts val="500"/>
-              </a:spcBef>
-              <a:buFont typeface="Arial" panose="020B0604020202020204" pitchFamily="34" charset="0"/>
-              <a:buChar char="•"/>
-              <a:defRPr sz="1800" kern="1200">
-                <a:solidFill>
-                  <a:schemeClr val="tx1"/>
-                </a:solidFill>
-                <a:latin typeface="+mn-lt"/>
-                <a:ea typeface="+mn-ea"/>
-                <a:cs typeface="+mn-cs"/>
-              </a:defRPr>
-            </a:lvl6pPr>
-            <a:lvl7pPr marL="2971800" indent="-228600" algn="l" defTabSz="914400" rtl="0" eaLnBrk="1" latinLnBrk="0" hangingPunct="1">
-              <a:lnSpc>
-                <a:spcPct val="90000"/>
-              </a:lnSpc>
-              <a:spcBef>
-                <a:spcPts val="500"/>
-              </a:spcBef>
-              <a:buFont typeface="Arial" panose="020B0604020202020204" pitchFamily="34" charset="0"/>
-              <a:buChar char="•"/>
-              <a:defRPr sz="1800" kern="1200">
-                <a:solidFill>
-                  <a:schemeClr val="tx1"/>
-                </a:solidFill>
-                <a:latin typeface="+mn-lt"/>
-                <a:ea typeface="+mn-ea"/>
-                <a:cs typeface="+mn-cs"/>
-              </a:defRPr>
-            </a:lvl7pPr>
-            <a:lvl8pPr marL="3429000" indent="-228600" algn="l" defTabSz="914400" rtl="0" eaLnBrk="1" latinLnBrk="0" hangingPunct="1">
-              <a:lnSpc>
-                <a:spcPct val="90000"/>
-              </a:lnSpc>
-              <a:spcBef>
-                <a:spcPts val="500"/>
-              </a:spcBef>
-              <a:buFont typeface="Arial" panose="020B0604020202020204" pitchFamily="34" charset="0"/>
-              <a:buChar char="•"/>
-              <a:defRPr sz="1800" kern="1200">
-                <a:solidFill>
-                  <a:schemeClr val="tx1"/>
-                </a:solidFill>
-                <a:latin typeface="+mn-lt"/>
-                <a:ea typeface="+mn-ea"/>
-                <a:cs typeface="+mn-cs"/>
-              </a:defRPr>
-            </a:lvl8pPr>
-            <a:lvl9pPr marL="3886200" indent="-228600" algn="l" defTabSz="914400" rtl="0" eaLnBrk="1" latinLnBrk="0" hangingPunct="1">
-              <a:lnSpc>
-                <a:spcPct val="90000"/>
-              </a:lnSpc>
-              <a:spcBef>
-                <a:spcPts val="500"/>
-              </a:spcBef>
-              <a:buFont typeface="Arial" panose="020B0604020202020204" pitchFamily="34" charset="0"/>
-              <a:buChar char="•"/>
-              <a:defRPr sz="1800" kern="1200">
-                <a:solidFill>
-                  <a:schemeClr val="tx1"/>
-                </a:solidFill>
-                <a:latin typeface="+mn-lt"/>
-                <a:ea typeface="+mn-ea"/>
-                <a:cs typeface="+mn-cs"/>
-              </a:defRPr>
-            </a:lvl9pPr>
-          </a:lstStyle>
-          <a:p>
-            <a:pPr marL="0" indent="0">
-              <a:buNone/>
-            </a:pPr>
-            <a:r>
-              <a:rPr lang="en-NL" sz="1800" b="1" dirty="0"/>
-              <a:t>September</a:t>
-            </a:r>
-            <a:endParaRPr lang="en-NL" sz="1800" i="1" dirty="0"/>
-          </a:p>
-        </p:txBody>
-      </p:sp>
-      <p:sp>
-        <p:nvSpPr>
-          <p:cNvPr id="8" name="Content Placeholder 2">
-            <a:extLst>
-              <a:ext uri="{FF2B5EF4-FFF2-40B4-BE49-F238E27FC236}">
-                <a16:creationId xmlns:a16="http://schemas.microsoft.com/office/drawing/2014/main" id="{2DCE9F8F-2589-70D3-E4A6-66176505617E}"/>
-              </a:ext>
-            </a:extLst>
-          </p:cNvPr>
-          <p:cNvSpPr txBox="1">
-            <a:spLocks/>
-          </p:cNvSpPr>
-          <p:nvPr/>
-        </p:nvSpPr>
-        <p:spPr>
-          <a:xfrm>
-            <a:off x="3163126" y="21890"/>
-            <a:ext cx="1365661" cy="343235"/>
-          </a:xfrm>
-          <a:prstGeom prst="rect">
-            <a:avLst/>
-          </a:prstGeom>
-        </p:spPr>
-        <p:txBody>
-          <a:bodyPr vert="horz" wrap="square" lIns="91440" tIns="45720" rIns="91440" bIns="45720" rtlCol="0">
-            <a:spAutoFit/>
-          </a:bodyPr>
-          <a:lstStyle>
-            <a:lvl1pPr marL="228600" indent="-228600" algn="l" defTabSz="914400" rtl="0" eaLnBrk="1" latinLnBrk="0" hangingPunct="1">
-              <a:lnSpc>
-                <a:spcPct val="90000"/>
-              </a:lnSpc>
-              <a:spcBef>
-                <a:spcPts val="1000"/>
-              </a:spcBef>
-              <a:buFont typeface="Arial" panose="020B0604020202020204" pitchFamily="34" charset="0"/>
-              <a:buChar char="•"/>
-              <a:defRPr sz="2800" kern="1200">
-                <a:solidFill>
-                  <a:schemeClr val="tx1"/>
-                </a:solidFill>
-                <a:latin typeface="+mn-lt"/>
-                <a:ea typeface="+mn-ea"/>
-                <a:cs typeface="+mn-cs"/>
-              </a:defRPr>
-            </a:lvl1pPr>
-            <a:lvl2pPr marL="685800" indent="-228600" algn="l" defTabSz="914400" rtl="0" eaLnBrk="1" latinLnBrk="0" hangingPunct="1">
-              <a:lnSpc>
-                <a:spcPct val="90000"/>
-              </a:lnSpc>
-              <a:spcBef>
-                <a:spcPts val="500"/>
-              </a:spcBef>
-              <a:buFont typeface="Arial" panose="020B0604020202020204" pitchFamily="34" charset="0"/>
-              <a:buChar char="•"/>
-              <a:defRPr sz="2400" kern="1200">
-                <a:solidFill>
-                  <a:schemeClr val="tx1"/>
-                </a:solidFill>
-                <a:latin typeface="+mn-lt"/>
-                <a:ea typeface="+mn-ea"/>
-                <a:cs typeface="+mn-cs"/>
-              </a:defRPr>
-            </a:lvl2pPr>
-            <a:lvl3pPr marL="1143000" indent="-228600" algn="l" defTabSz="914400" rtl="0" eaLnBrk="1" latinLnBrk="0" hangingPunct="1">
-              <a:lnSpc>
-                <a:spcPct val="90000"/>
-              </a:lnSpc>
-              <a:spcBef>
-                <a:spcPts val="500"/>
-              </a:spcBef>
-              <a:buFont typeface="Arial" panose="020B0604020202020204" pitchFamily="34" charset="0"/>
-              <a:buChar char="•"/>
-              <a:defRPr sz="2000" kern="1200">
-                <a:solidFill>
-                  <a:schemeClr val="tx1"/>
-                </a:solidFill>
-                <a:latin typeface="+mn-lt"/>
-                <a:ea typeface="+mn-ea"/>
-                <a:cs typeface="+mn-cs"/>
-              </a:defRPr>
-            </a:lvl3pPr>
-            <a:lvl4pPr marL="1600200" indent="-228600" algn="l" defTabSz="914400" rtl="0" eaLnBrk="1" latinLnBrk="0" hangingPunct="1">
-              <a:lnSpc>
-                <a:spcPct val="90000"/>
-              </a:lnSpc>
-              <a:spcBef>
-                <a:spcPts val="500"/>
-              </a:spcBef>
-              <a:buFont typeface="Arial" panose="020B0604020202020204" pitchFamily="34" charset="0"/>
-              <a:buChar char="•"/>
-              <a:defRPr sz="1800" kern="1200">
-                <a:solidFill>
-                  <a:schemeClr val="tx1"/>
-                </a:solidFill>
-                <a:latin typeface="+mn-lt"/>
-                <a:ea typeface="+mn-ea"/>
-                <a:cs typeface="+mn-cs"/>
-              </a:defRPr>
-            </a:lvl4pPr>
-            <a:lvl5pPr marL="2057400" indent="-228600" algn="l" defTabSz="914400" rtl="0" eaLnBrk="1" latinLnBrk="0" hangingPunct="1">
-              <a:lnSpc>
-                <a:spcPct val="90000"/>
-              </a:lnSpc>
-              <a:spcBef>
-                <a:spcPts val="500"/>
-              </a:spcBef>
-              <a:buFont typeface="Arial" panose="020B0604020202020204" pitchFamily="34" charset="0"/>
-              <a:buChar char="•"/>
-              <a:defRPr sz="1800" kern="1200">
-                <a:solidFill>
-                  <a:schemeClr val="tx1"/>
-                </a:solidFill>
-                <a:latin typeface="+mn-lt"/>
-                <a:ea typeface="+mn-ea"/>
-                <a:cs typeface="+mn-cs"/>
-              </a:defRPr>
-            </a:lvl5pPr>
-            <a:lvl6pPr marL="2514600" indent="-228600" algn="l" defTabSz="914400" rtl="0" eaLnBrk="1" latinLnBrk="0" hangingPunct="1">
-              <a:lnSpc>
-                <a:spcPct val="90000"/>
-              </a:lnSpc>
-              <a:spcBef>
-                <a:spcPts val="500"/>
-              </a:spcBef>
-              <a:buFont typeface="Arial" panose="020B0604020202020204" pitchFamily="34" charset="0"/>
-              <a:buChar char="•"/>
-              <a:defRPr sz="1800" kern="1200">
-                <a:solidFill>
-                  <a:schemeClr val="tx1"/>
-                </a:solidFill>
-                <a:latin typeface="+mn-lt"/>
-                <a:ea typeface="+mn-ea"/>
-                <a:cs typeface="+mn-cs"/>
-              </a:defRPr>
-            </a:lvl6pPr>
-            <a:lvl7pPr marL="2971800" indent="-228600" algn="l" defTabSz="914400" rtl="0" eaLnBrk="1" latinLnBrk="0" hangingPunct="1">
-              <a:lnSpc>
-                <a:spcPct val="90000"/>
-              </a:lnSpc>
-              <a:spcBef>
-                <a:spcPts val="500"/>
-              </a:spcBef>
-              <a:buFont typeface="Arial" panose="020B0604020202020204" pitchFamily="34" charset="0"/>
-              <a:buChar char="•"/>
-              <a:defRPr sz="1800" kern="1200">
-                <a:solidFill>
-                  <a:schemeClr val="tx1"/>
-                </a:solidFill>
-                <a:latin typeface="+mn-lt"/>
-                <a:ea typeface="+mn-ea"/>
-                <a:cs typeface="+mn-cs"/>
-              </a:defRPr>
-            </a:lvl7pPr>
-            <a:lvl8pPr marL="3429000" indent="-228600" algn="l" defTabSz="914400" rtl="0" eaLnBrk="1" latinLnBrk="0" hangingPunct="1">
-              <a:lnSpc>
-                <a:spcPct val="90000"/>
-              </a:lnSpc>
-              <a:spcBef>
-                <a:spcPts val="500"/>
-              </a:spcBef>
-              <a:buFont typeface="Arial" panose="020B0604020202020204" pitchFamily="34" charset="0"/>
-              <a:buChar char="•"/>
-              <a:defRPr sz="1800" kern="1200">
-                <a:solidFill>
-                  <a:schemeClr val="tx1"/>
-                </a:solidFill>
-                <a:latin typeface="+mn-lt"/>
-                <a:ea typeface="+mn-ea"/>
-                <a:cs typeface="+mn-cs"/>
-              </a:defRPr>
-            </a:lvl8pPr>
-            <a:lvl9pPr marL="3886200" indent="-228600" algn="l" defTabSz="914400" rtl="0" eaLnBrk="1" latinLnBrk="0" hangingPunct="1">
-              <a:lnSpc>
-                <a:spcPct val="90000"/>
-              </a:lnSpc>
-              <a:spcBef>
-                <a:spcPts val="500"/>
-              </a:spcBef>
-              <a:buFont typeface="Arial" panose="020B0604020202020204" pitchFamily="34" charset="0"/>
-              <a:buChar char="•"/>
-              <a:defRPr sz="1800" kern="1200">
-                <a:solidFill>
-                  <a:schemeClr val="tx1"/>
-                </a:solidFill>
-                <a:latin typeface="+mn-lt"/>
-                <a:ea typeface="+mn-ea"/>
-                <a:cs typeface="+mn-cs"/>
-              </a:defRPr>
-            </a:lvl9pPr>
-          </a:lstStyle>
-          <a:p>
-            <a:pPr marL="0" indent="0">
-              <a:buNone/>
-            </a:pPr>
-            <a:r>
-              <a:rPr lang="en-NL" sz="1800" b="1" dirty="0"/>
-              <a:t>October</a:t>
-            </a:r>
-            <a:endParaRPr lang="en-NL" sz="1800" i="1" dirty="0"/>
-          </a:p>
-        </p:txBody>
-      </p:sp>
-      <p:sp>
-        <p:nvSpPr>
-          <p:cNvPr id="9" name="Rectangle 8">
-            <a:extLst>
-              <a:ext uri="{FF2B5EF4-FFF2-40B4-BE49-F238E27FC236}">
-                <a16:creationId xmlns:a16="http://schemas.microsoft.com/office/drawing/2014/main" id="{DAFB605B-CA8A-35D4-292C-C8CFD6242FA8}"/>
+          <p:cNvPr id="7" name="Rectangle 6">
+            <a:extLst>
+              <a:ext uri="{FF2B5EF4-FFF2-40B4-BE49-F238E27FC236}">
+                <a16:creationId xmlns:a16="http://schemas.microsoft.com/office/drawing/2014/main" id="{037E0103-C3AE-3147-92B1-FE9A7D859218}"/>
               </a:ext>
             </a:extLst>
           </p:cNvPr>
@@ -13803,8 +12860,8 @@
         </p:nvSpPr>
         <p:spPr>
           <a:xfrm>
-            <a:off x="5404210" y="2421980"/>
-            <a:ext cx="1380778" cy="2147746"/>
+            <a:off x="6021897" y="2838994"/>
+            <a:ext cx="1380778" cy="1430830"/>
           </a:xfrm>
           <a:prstGeom prst="rect">
             <a:avLst/>
@@ -13843,10 +12900,71 @@
           </a:p>
         </p:txBody>
       </p:sp>
+      <p:pic>
+        <p:nvPicPr>
+          <p:cNvPr id="8" name="Content Placeholder 3" descr="Inaugural lecture by Aalt-Jan van Dijk - SILS - University of Amsterdam">
+            <a:extLst>
+              <a:ext uri="{FF2B5EF4-FFF2-40B4-BE49-F238E27FC236}">
+                <a16:creationId xmlns:a16="http://schemas.microsoft.com/office/drawing/2014/main" id="{3F3C7A12-8034-6826-5D7F-AC31AF50FF0C}"/>
+              </a:ext>
+            </a:extLst>
+          </p:cNvPr>
+          <p:cNvPicPr>
+            <a:picLocks noChangeAspect="1"/>
+          </p:cNvPicPr>
+          <p:nvPr/>
+        </p:nvPicPr>
+        <p:blipFill>
+          <a:blip r:embed="rId4"/>
+          <a:srcRect l="25698" t="5908" r="13797" b="9355"/>
+          <a:stretch>
+            <a:fillRect/>
+          </a:stretch>
+        </p:blipFill>
+        <p:spPr>
+          <a:xfrm>
+            <a:off x="8656576" y="4686635"/>
+            <a:ext cx="1733328" cy="1616057"/>
+          </a:xfrm>
+          <a:prstGeom prst="ellipse">
+            <a:avLst/>
+          </a:prstGeom>
+        </p:spPr>
+      </p:pic>
+      <p:pic>
+        <p:nvPicPr>
+          <p:cNvPr id="9" name="Picture 8">
+            <a:extLst>
+              <a:ext uri="{FF2B5EF4-FFF2-40B4-BE49-F238E27FC236}">
+                <a16:creationId xmlns:a16="http://schemas.microsoft.com/office/drawing/2014/main" id="{6B3DC47C-C4D6-36AF-731F-3275986F339A}"/>
+              </a:ext>
+            </a:extLst>
+          </p:cNvPr>
+          <p:cNvPicPr>
+            <a:picLocks noChangeAspect="1"/>
+          </p:cNvPicPr>
+          <p:nvPr/>
+        </p:nvPicPr>
+        <p:blipFill>
+          <a:blip r:embed="rId5"/>
+          <a:stretch>
+            <a:fillRect/>
+          </a:stretch>
+        </p:blipFill>
+        <p:spPr>
+          <a:xfrm>
+            <a:off x="10629687" y="4629848"/>
+            <a:ext cx="1251279" cy="1729630"/>
+          </a:xfrm>
+          <a:prstGeom prst="ellipse">
+            <a:avLst/>
+          </a:prstGeom>
+        </p:spPr>
+      </p:pic>
     </p:spTree>
     <p:extLst>
       <p:ext uri="{BB962C8B-B14F-4D97-AF65-F5344CB8AC3E}">
-        <p14:creationId xmlns:p14="http://schemas.microsoft.com/office/powerpoint/2010/main" val="2378014723"/>
+        <p14:creationId xmlns:p14="http://schemas.microsoft.com/office/powerpoint/2010/main" val="2492037586"/>
       </p:ext>
     </p:extLst>
   </p:cSld>
@@ -13864,7 +12982,7 @@
         <p:cNvPr id="1" name="">
           <a:extLst>
             <a:ext uri="{FF2B5EF4-FFF2-40B4-BE49-F238E27FC236}">
-              <a16:creationId xmlns:a16="http://schemas.microsoft.com/office/drawing/2014/main" id="{4301B1F3-88A0-F20B-32E7-67E641E46CB8}"/>
+              <a16:creationId xmlns:a16="http://schemas.microsoft.com/office/drawing/2014/main" id="{38DE947C-898F-F3BA-58B5-45EE5E9D5718}"/>
             </a:ext>
           </a:extLst>
         </p:cNvPr>
@@ -13881,10 +12999,10 @@
       </p:grpSpPr>
       <p:pic>
         <p:nvPicPr>
-          <p:cNvPr id="3" name="Picture 2">
-            <a:extLst>
-              <a:ext uri="{FF2B5EF4-FFF2-40B4-BE49-F238E27FC236}">
-                <a16:creationId xmlns:a16="http://schemas.microsoft.com/office/drawing/2014/main" id="{612B39C4-52C5-4B62-E10A-9BD7C3901A1E}"/>
+          <p:cNvPr id="4" name="Picture 3">
+            <a:extLst>
+              <a:ext uri="{FF2B5EF4-FFF2-40B4-BE49-F238E27FC236}">
+                <a16:creationId xmlns:a16="http://schemas.microsoft.com/office/drawing/2014/main" id="{91AEB53C-95A4-DBE1-35EA-59DB6E969B32}"/>
               </a:ext>
             </a:extLst>
           </p:cNvPr>
@@ -13895,15 +13013,14 @@
         </p:nvPicPr>
         <p:blipFill>
           <a:blip r:embed="rId2"/>
-          <a:srcRect l="9369" t="10412" r="2204"/>
           <a:stretch>
             <a:fillRect/>
           </a:stretch>
         </p:blipFill>
         <p:spPr>
           <a:xfrm>
-            <a:off x="114270" y="277883"/>
-            <a:ext cx="5374362" cy="4377530"/>
+            <a:off x="202990" y="233234"/>
+            <a:ext cx="5801650" cy="4917886"/>
           </a:xfrm>
           <a:prstGeom prst="rect">
             <a:avLst/>
@@ -13912,10 +13029,10 @@
       </p:pic>
       <p:pic>
         <p:nvPicPr>
-          <p:cNvPr id="8" name="Picture 7">
-            <a:extLst>
-              <a:ext uri="{FF2B5EF4-FFF2-40B4-BE49-F238E27FC236}">
-                <a16:creationId xmlns:a16="http://schemas.microsoft.com/office/drawing/2014/main" id="{5D54B27F-0377-4946-9403-05B803AD45AF}"/>
+          <p:cNvPr id="5" name="Picture 4">
+            <a:extLst>
+              <a:ext uri="{FF2B5EF4-FFF2-40B4-BE49-F238E27FC236}">
+                <a16:creationId xmlns:a16="http://schemas.microsoft.com/office/drawing/2014/main" id="{67F75276-DDB1-C0E2-3C9E-C7856E903906}"/>
               </a:ext>
             </a:extLst>
           </p:cNvPr>
@@ -13926,15 +13043,14 @@
         </p:nvPicPr>
         <p:blipFill>
           <a:blip r:embed="rId3"/>
-          <a:srcRect l="8823" r="3406"/>
           <a:stretch>
             <a:fillRect/>
           </a:stretch>
         </p:blipFill>
         <p:spPr>
           <a:xfrm>
-            <a:off x="5636212" y="2425629"/>
-            <a:ext cx="5374362" cy="4377530"/>
+            <a:off x="6096000" y="1951354"/>
+            <a:ext cx="6045252" cy="4794885"/>
           </a:xfrm>
           <a:prstGeom prst="rect">
             <a:avLst/>
@@ -13943,29 +13059,50 @@
       </p:pic>
       <p:sp>
         <p:nvSpPr>
-          <p:cNvPr id="2" name="Title 1">
-            <a:extLst>
-              <a:ext uri="{FF2B5EF4-FFF2-40B4-BE49-F238E27FC236}">
-                <a16:creationId xmlns:a16="http://schemas.microsoft.com/office/drawing/2014/main" id="{8E6253B2-8F2E-D473-77B8-8E65D9E294A4}"/>
-              </a:ext>
-            </a:extLst>
-          </p:cNvPr>
-          <p:cNvSpPr>
-            <a:spLocks noGrp="1"/>
+          <p:cNvPr id="10" name="Title 1">
+            <a:extLst>
+              <a:ext uri="{FF2B5EF4-FFF2-40B4-BE49-F238E27FC236}">
+                <a16:creationId xmlns:a16="http://schemas.microsoft.com/office/drawing/2014/main" id="{799A06A1-9420-BCD8-F0B8-5988845A5C4F}"/>
+              </a:ext>
+            </a:extLst>
+          </p:cNvPr>
+          <p:cNvSpPr txBox="1">
+            <a:spLocks/>
           </p:cNvSpPr>
-          <p:nvPr>
-            <p:ph type="title"/>
-          </p:nvPr>
+          <p:nvPr/>
         </p:nvSpPr>
         <p:spPr>
           <a:xfrm>
-            <a:off x="6923024" y="555329"/>
+            <a:off x="7184281" y="455334"/>
             <a:ext cx="5154706" cy="1325563"/>
           </a:xfrm>
+          <a:prstGeom prst="rect">
+            <a:avLst/>
+          </a:prstGeom>
         </p:spPr>
         <p:txBody>
-          <a:bodyPr/>
-          <a:lstStyle/>
+          <a:bodyPr vert="horz" lIns="91440" tIns="45720" rIns="91440" bIns="45720" rtlCol="0" anchor="ctr">
+            <a:normAutofit/>
+          </a:bodyPr>
+          <a:lstStyle>
+            <a:lvl1pPr algn="l" defTabSz="914400" rtl="0" eaLnBrk="1" latinLnBrk="0" hangingPunct="1">
+              <a:lnSpc>
+                <a:spcPct val="90000"/>
+              </a:lnSpc>
+              <a:spcBef>
+                <a:spcPct val="0"/>
+              </a:spcBef>
+              <a:buNone/>
+              <a:defRPr sz="4400" kern="1200">
+                <a:solidFill>
+                  <a:schemeClr val="tx1"/>
+                </a:solidFill>
+                <a:latin typeface="+mj-lt"/>
+                <a:ea typeface="+mj-ea"/>
+                <a:cs typeface="+mj-cs"/>
+              </a:defRPr>
+            </a:lvl1pPr>
+          </a:lstStyle>
           <a:p>
             <a:r>
               <a:rPr lang="en-NL" b="1" dirty="0"/>
@@ -13976,10 +13113,10 @@
       </p:sp>
       <p:sp>
         <p:nvSpPr>
-          <p:cNvPr id="6" name="TextBox 5">
-            <a:extLst>
-              <a:ext uri="{FF2B5EF4-FFF2-40B4-BE49-F238E27FC236}">
-                <a16:creationId xmlns:a16="http://schemas.microsoft.com/office/drawing/2014/main" id="{42442613-A333-151E-2CF8-0E0B101226D7}"/>
+          <p:cNvPr id="11" name="TextBox 10">
+            <a:extLst>
+              <a:ext uri="{FF2B5EF4-FFF2-40B4-BE49-F238E27FC236}">
+                <a16:creationId xmlns:a16="http://schemas.microsoft.com/office/drawing/2014/main" id="{4309DBC0-51F1-D669-32AF-90C352B18290}"/>
               </a:ext>
             </a:extLst>
           </p:cNvPr>
@@ -14016,10 +13153,10 @@
       </p:sp>
       <p:cxnSp>
         <p:nvCxnSpPr>
-          <p:cNvPr id="7" name="Straight Arrow Connector 6">
-            <a:extLst>
-              <a:ext uri="{FF2B5EF4-FFF2-40B4-BE49-F238E27FC236}">
-                <a16:creationId xmlns:a16="http://schemas.microsoft.com/office/drawing/2014/main" id="{F4CBDCFB-86C2-45AD-58AA-3AAFD07F5CB5}"/>
+          <p:cNvPr id="12" name="Straight Arrow Connector 11">
+            <a:extLst>
+              <a:ext uri="{FF2B5EF4-FFF2-40B4-BE49-F238E27FC236}">
+                <a16:creationId xmlns:a16="http://schemas.microsoft.com/office/drawing/2014/main" id="{D70C19FA-22C2-D935-385F-F7AFAF437788}"/>
               </a:ext>
             </a:extLst>
           </p:cNvPr>
@@ -14030,8 +13167,8 @@
         </p:nvCxnSpPr>
         <p:spPr>
           <a:xfrm flipH="1" flipV="1">
-            <a:off x="1929654" y="4995665"/>
-            <a:ext cx="1532952" cy="376245"/>
+            <a:off x="2508069" y="5077097"/>
+            <a:ext cx="954537" cy="294813"/>
           </a:xfrm>
           <a:prstGeom prst="straightConnector1">
             <a:avLst/>
@@ -14060,10 +13197,10 @@
       </p:cxnSp>
       <p:sp>
         <p:nvSpPr>
-          <p:cNvPr id="10" name="Oval 9">
-            <a:extLst>
-              <a:ext uri="{FF2B5EF4-FFF2-40B4-BE49-F238E27FC236}">
-                <a16:creationId xmlns:a16="http://schemas.microsoft.com/office/drawing/2014/main" id="{3C4A069D-CEF3-C3C9-13CE-5170F63F5FC7}"/>
+          <p:cNvPr id="13" name="Oval 12">
+            <a:extLst>
+              <a:ext uri="{FF2B5EF4-FFF2-40B4-BE49-F238E27FC236}">
+                <a16:creationId xmlns:a16="http://schemas.microsoft.com/office/drawing/2014/main" id="{DA7CB10E-9ED8-88B6-68F8-220BACD0F19B}"/>
               </a:ext>
             </a:extLst>
           </p:cNvPr>
@@ -14072,8 +13209,8 @@
         </p:nvSpPr>
         <p:spPr>
           <a:xfrm>
-            <a:off x="-33310" y="3549312"/>
-            <a:ext cx="2595282" cy="1139123"/>
+            <a:off x="1205725" y="3989026"/>
+            <a:ext cx="1434352" cy="1234529"/>
           </a:xfrm>
           <a:prstGeom prst="ellipse">
             <a:avLst/>
@@ -14112,10 +13249,10 @@
       </p:sp>
       <p:sp>
         <p:nvSpPr>
-          <p:cNvPr id="11" name="Oval 10">
-            <a:extLst>
-              <a:ext uri="{FF2B5EF4-FFF2-40B4-BE49-F238E27FC236}">
-                <a16:creationId xmlns:a16="http://schemas.microsoft.com/office/drawing/2014/main" id="{25060021-58A6-9F3C-2BCE-041FC0C82BC0}"/>
+          <p:cNvPr id="14" name="Oval 13">
+            <a:extLst>
+              <a:ext uri="{FF2B5EF4-FFF2-40B4-BE49-F238E27FC236}">
+                <a16:creationId xmlns:a16="http://schemas.microsoft.com/office/drawing/2014/main" id="{66180557-5659-19E6-B7E4-2A7FC8975FFE}"/>
               </a:ext>
             </a:extLst>
           </p:cNvPr>
@@ -14124,7 +13261,7 @@
         </p:nvSpPr>
         <p:spPr>
           <a:xfrm>
-            <a:off x="6642849" y="5727673"/>
+            <a:off x="7184281" y="5587178"/>
             <a:ext cx="1434352" cy="1139123"/>
           </a:xfrm>
           <a:prstGeom prst="ellipse">
@@ -14164,10 +13301,10 @@
       </p:sp>
       <p:cxnSp>
         <p:nvCxnSpPr>
-          <p:cNvPr id="13" name="Straight Arrow Connector 12">
-            <a:extLst>
-              <a:ext uri="{FF2B5EF4-FFF2-40B4-BE49-F238E27FC236}">
-                <a16:creationId xmlns:a16="http://schemas.microsoft.com/office/drawing/2014/main" id="{430EAF45-6F01-F3C6-002A-BDFA62DD4851}"/>
+          <p:cNvPr id="15" name="Straight Arrow Connector 14">
+            <a:extLst>
+              <a:ext uri="{FF2B5EF4-FFF2-40B4-BE49-F238E27FC236}">
+                <a16:creationId xmlns:a16="http://schemas.microsoft.com/office/drawing/2014/main" id="{17BEAE34-8114-5722-9505-1F845833437F}"/>
               </a:ext>
             </a:extLst>
           </p:cNvPr>
@@ -14179,7 +13316,7 @@
         <p:spPr>
           <a:xfrm>
             <a:off x="5029214" y="5484141"/>
-            <a:ext cx="1613635" cy="441767"/>
+            <a:ext cx="1989895" cy="477891"/>
           </a:xfrm>
           <a:prstGeom prst="straightConnector1">
             <a:avLst/>
@@ -14208,22 +13345,23 @@
       </p:cxnSp>
       <p:cxnSp>
         <p:nvCxnSpPr>
-          <p:cNvPr id="19" name="Straight Arrow Connector 18">
-            <a:extLst>
-              <a:ext uri="{FF2B5EF4-FFF2-40B4-BE49-F238E27FC236}">
-                <a16:creationId xmlns:a16="http://schemas.microsoft.com/office/drawing/2014/main" id="{5719205A-E377-145D-661C-2BD22BFE9E65}"/>
+          <p:cNvPr id="16" name="Straight Arrow Connector 15">
+            <a:extLst>
+              <a:ext uri="{FF2B5EF4-FFF2-40B4-BE49-F238E27FC236}">
+                <a16:creationId xmlns:a16="http://schemas.microsoft.com/office/drawing/2014/main" id="{FDCB7697-B7A8-B91A-CC15-2E77180C6124}"/>
               </a:ext>
             </a:extLst>
           </p:cNvPr>
           <p:cNvCxnSpPr>
             <a:cxnSpLocks/>
+            <a:endCxn id="5" idx="1"/>
           </p:cNvCxnSpPr>
           <p:nvPr/>
         </p:nvCxnSpPr>
         <p:spPr>
           <a:xfrm flipV="1">
-            <a:off x="4995558" y="4734859"/>
-            <a:ext cx="1100442" cy="511237"/>
+            <a:off x="4995558" y="4348797"/>
+            <a:ext cx="1100442" cy="897299"/>
           </a:xfrm>
           <a:prstGeom prst="straightConnector1">
             <a:avLst/>
@@ -14252,10 +13390,10 @@
       </p:cxnSp>
       <p:sp>
         <p:nvSpPr>
-          <p:cNvPr id="21" name="Oval 20">
-            <a:extLst>
-              <a:ext uri="{FF2B5EF4-FFF2-40B4-BE49-F238E27FC236}">
-                <a16:creationId xmlns:a16="http://schemas.microsoft.com/office/drawing/2014/main" id="{8AF530A4-FCCF-887C-8D3D-2BAA4082CCFB}"/>
+          <p:cNvPr id="17" name="Oval 16">
+            <a:extLst>
+              <a:ext uri="{FF2B5EF4-FFF2-40B4-BE49-F238E27FC236}">
+                <a16:creationId xmlns:a16="http://schemas.microsoft.com/office/drawing/2014/main" id="{A227BA31-70FF-E00E-5E42-269E0C02925A}"/>
               </a:ext>
             </a:extLst>
           </p:cNvPr>
@@ -14264,7 +13402,7 @@
         </p:nvSpPr>
         <p:spPr>
           <a:xfrm>
-            <a:off x="5587232" y="4194695"/>
+            <a:off x="6004641" y="3770935"/>
             <a:ext cx="1434352" cy="460718"/>
           </a:xfrm>
           <a:prstGeom prst="ellipse">
@@ -14304,10 +13442,10 @@
       </p:sp>
       <p:sp>
         <p:nvSpPr>
-          <p:cNvPr id="22" name="TextBox 21">
-            <a:extLst>
-              <a:ext uri="{FF2B5EF4-FFF2-40B4-BE49-F238E27FC236}">
-                <a16:creationId xmlns:a16="http://schemas.microsoft.com/office/drawing/2014/main" id="{A4D95920-47E9-0396-C51F-CF40FFD29E21}"/>
+          <p:cNvPr id="18" name="TextBox 17">
+            <a:extLst>
+              <a:ext uri="{FF2B5EF4-FFF2-40B4-BE49-F238E27FC236}">
+                <a16:creationId xmlns:a16="http://schemas.microsoft.com/office/drawing/2014/main" id="{72E67A3D-FDCC-27E4-C9AA-DAA02979795A}"/>
               </a:ext>
             </a:extLst>
           </p:cNvPr>
@@ -14362,416 +13500,10 @@
           </a:p>
         </p:txBody>
       </p:sp>
-      <p:sp>
-        <p:nvSpPr>
-          <p:cNvPr id="4" name="Content Placeholder 2">
-            <a:extLst>
-              <a:ext uri="{FF2B5EF4-FFF2-40B4-BE49-F238E27FC236}">
-                <a16:creationId xmlns:a16="http://schemas.microsoft.com/office/drawing/2014/main" id="{8CEEAAC4-2C4F-47F3-AD62-58D0E470F625}"/>
-              </a:ext>
-            </a:extLst>
-          </p:cNvPr>
-          <p:cNvSpPr txBox="1">
-            <a:spLocks/>
-          </p:cNvSpPr>
-          <p:nvPr/>
-        </p:nvSpPr>
-        <p:spPr>
-          <a:xfrm>
-            <a:off x="165684" y="49965"/>
-            <a:ext cx="1365661" cy="343235"/>
-          </a:xfrm>
-          <a:prstGeom prst="rect">
-            <a:avLst/>
-          </a:prstGeom>
-        </p:spPr>
-        <p:txBody>
-          <a:bodyPr vert="horz" wrap="square" lIns="91440" tIns="45720" rIns="91440" bIns="45720" rtlCol="0">
-            <a:spAutoFit/>
-          </a:bodyPr>
-          <a:lstStyle>
-            <a:lvl1pPr marL="228600" indent="-228600" algn="l" defTabSz="914400" rtl="0" eaLnBrk="1" latinLnBrk="0" hangingPunct="1">
-              <a:lnSpc>
-                <a:spcPct val="90000"/>
-              </a:lnSpc>
-              <a:spcBef>
-                <a:spcPts val="1000"/>
-              </a:spcBef>
-              <a:buFont typeface="Arial" panose="020B0604020202020204" pitchFamily="34" charset="0"/>
-              <a:buChar char="•"/>
-              <a:defRPr sz="2800" kern="1200">
-                <a:solidFill>
-                  <a:schemeClr val="tx1"/>
-                </a:solidFill>
-                <a:latin typeface="+mn-lt"/>
-                <a:ea typeface="+mn-ea"/>
-                <a:cs typeface="+mn-cs"/>
-              </a:defRPr>
-            </a:lvl1pPr>
-            <a:lvl2pPr marL="685800" indent="-228600" algn="l" defTabSz="914400" rtl="0" eaLnBrk="1" latinLnBrk="0" hangingPunct="1">
-              <a:lnSpc>
-                <a:spcPct val="90000"/>
-              </a:lnSpc>
-              <a:spcBef>
-                <a:spcPts val="500"/>
-              </a:spcBef>
-              <a:buFont typeface="Arial" panose="020B0604020202020204" pitchFamily="34" charset="0"/>
-              <a:buChar char="•"/>
-              <a:defRPr sz="2400" kern="1200">
-                <a:solidFill>
-                  <a:schemeClr val="tx1"/>
-                </a:solidFill>
-                <a:latin typeface="+mn-lt"/>
-                <a:ea typeface="+mn-ea"/>
-                <a:cs typeface="+mn-cs"/>
-              </a:defRPr>
-            </a:lvl2pPr>
-            <a:lvl3pPr marL="1143000" indent="-228600" algn="l" defTabSz="914400" rtl="0" eaLnBrk="1" latinLnBrk="0" hangingPunct="1">
-              <a:lnSpc>
-                <a:spcPct val="90000"/>
-              </a:lnSpc>
-              <a:spcBef>
-                <a:spcPts val="500"/>
-              </a:spcBef>
-              <a:buFont typeface="Arial" panose="020B0604020202020204" pitchFamily="34" charset="0"/>
-              <a:buChar char="•"/>
-              <a:defRPr sz="2000" kern="1200">
-                <a:solidFill>
-                  <a:schemeClr val="tx1"/>
-                </a:solidFill>
-                <a:latin typeface="+mn-lt"/>
-                <a:ea typeface="+mn-ea"/>
-                <a:cs typeface="+mn-cs"/>
-              </a:defRPr>
-            </a:lvl3pPr>
-            <a:lvl4pPr marL="1600200" indent="-228600" algn="l" defTabSz="914400" rtl="0" eaLnBrk="1" latinLnBrk="0" hangingPunct="1">
-              <a:lnSpc>
-                <a:spcPct val="90000"/>
-              </a:lnSpc>
-              <a:spcBef>
-                <a:spcPts val="500"/>
-              </a:spcBef>
-              <a:buFont typeface="Arial" panose="020B0604020202020204" pitchFamily="34" charset="0"/>
-              <a:buChar char="•"/>
-              <a:defRPr sz="1800" kern="1200">
-                <a:solidFill>
-                  <a:schemeClr val="tx1"/>
-                </a:solidFill>
-                <a:latin typeface="+mn-lt"/>
-                <a:ea typeface="+mn-ea"/>
-                <a:cs typeface="+mn-cs"/>
-              </a:defRPr>
-            </a:lvl4pPr>
-            <a:lvl5pPr marL="2057400" indent="-228600" algn="l" defTabSz="914400" rtl="0" eaLnBrk="1" latinLnBrk="0" hangingPunct="1">
-              <a:lnSpc>
-                <a:spcPct val="90000"/>
-              </a:lnSpc>
-              <a:spcBef>
-                <a:spcPts val="500"/>
-              </a:spcBef>
-              <a:buFont typeface="Arial" panose="020B0604020202020204" pitchFamily="34" charset="0"/>
-              <a:buChar char="•"/>
-              <a:defRPr sz="1800" kern="1200">
-                <a:solidFill>
-                  <a:schemeClr val="tx1"/>
-                </a:solidFill>
-                <a:latin typeface="+mn-lt"/>
-                <a:ea typeface="+mn-ea"/>
-                <a:cs typeface="+mn-cs"/>
-              </a:defRPr>
-            </a:lvl5pPr>
-            <a:lvl6pPr marL="2514600" indent="-228600" algn="l" defTabSz="914400" rtl="0" eaLnBrk="1" latinLnBrk="0" hangingPunct="1">
-              <a:lnSpc>
-                <a:spcPct val="90000"/>
-              </a:lnSpc>
-              <a:spcBef>
-                <a:spcPts val="500"/>
-              </a:spcBef>
-              <a:buFont typeface="Arial" panose="020B0604020202020204" pitchFamily="34" charset="0"/>
-              <a:buChar char="•"/>
-              <a:defRPr sz="1800" kern="1200">
-                <a:solidFill>
-                  <a:schemeClr val="tx1"/>
-                </a:solidFill>
-                <a:latin typeface="+mn-lt"/>
-                <a:ea typeface="+mn-ea"/>
-                <a:cs typeface="+mn-cs"/>
-              </a:defRPr>
-            </a:lvl6pPr>
-            <a:lvl7pPr marL="2971800" indent="-228600" algn="l" defTabSz="914400" rtl="0" eaLnBrk="1" latinLnBrk="0" hangingPunct="1">
-              <a:lnSpc>
-                <a:spcPct val="90000"/>
-              </a:lnSpc>
-              <a:spcBef>
-                <a:spcPts val="500"/>
-              </a:spcBef>
-              <a:buFont typeface="Arial" panose="020B0604020202020204" pitchFamily="34" charset="0"/>
-              <a:buChar char="•"/>
-              <a:defRPr sz="1800" kern="1200">
-                <a:solidFill>
-                  <a:schemeClr val="tx1"/>
-                </a:solidFill>
-                <a:latin typeface="+mn-lt"/>
-                <a:ea typeface="+mn-ea"/>
-                <a:cs typeface="+mn-cs"/>
-              </a:defRPr>
-            </a:lvl7pPr>
-            <a:lvl8pPr marL="3429000" indent="-228600" algn="l" defTabSz="914400" rtl="0" eaLnBrk="1" latinLnBrk="0" hangingPunct="1">
-              <a:lnSpc>
-                <a:spcPct val="90000"/>
-              </a:lnSpc>
-              <a:spcBef>
-                <a:spcPts val="500"/>
-              </a:spcBef>
-              <a:buFont typeface="Arial" panose="020B0604020202020204" pitchFamily="34" charset="0"/>
-              <a:buChar char="•"/>
-              <a:defRPr sz="1800" kern="1200">
-                <a:solidFill>
-                  <a:schemeClr val="tx1"/>
-                </a:solidFill>
-                <a:latin typeface="+mn-lt"/>
-                <a:ea typeface="+mn-ea"/>
-                <a:cs typeface="+mn-cs"/>
-              </a:defRPr>
-            </a:lvl8pPr>
-            <a:lvl9pPr marL="3886200" indent="-228600" algn="l" defTabSz="914400" rtl="0" eaLnBrk="1" latinLnBrk="0" hangingPunct="1">
-              <a:lnSpc>
-                <a:spcPct val="90000"/>
-              </a:lnSpc>
-              <a:spcBef>
-                <a:spcPts val="500"/>
-              </a:spcBef>
-              <a:buFont typeface="Arial" panose="020B0604020202020204" pitchFamily="34" charset="0"/>
-              <a:buChar char="•"/>
-              <a:defRPr sz="1800" kern="1200">
-                <a:solidFill>
-                  <a:schemeClr val="tx1"/>
-                </a:solidFill>
-                <a:latin typeface="+mn-lt"/>
-                <a:ea typeface="+mn-ea"/>
-                <a:cs typeface="+mn-cs"/>
-              </a:defRPr>
-            </a:lvl9pPr>
-          </a:lstStyle>
-          <a:p>
-            <a:pPr marL="0" indent="0">
-              <a:buNone/>
-            </a:pPr>
-            <a:r>
-              <a:rPr lang="en-NL" sz="1800" b="1" dirty="0"/>
-              <a:t>September</a:t>
-            </a:r>
-            <a:endParaRPr lang="en-NL" sz="1800" i="1" dirty="0"/>
-          </a:p>
-        </p:txBody>
-      </p:sp>
-      <p:sp>
-        <p:nvSpPr>
-          <p:cNvPr id="5" name="Content Placeholder 2">
-            <a:extLst>
-              <a:ext uri="{FF2B5EF4-FFF2-40B4-BE49-F238E27FC236}">
-                <a16:creationId xmlns:a16="http://schemas.microsoft.com/office/drawing/2014/main" id="{BFF530A4-5F14-AFD7-C8F9-9D42AF21B2F4}"/>
-              </a:ext>
-            </a:extLst>
-          </p:cNvPr>
-          <p:cNvSpPr txBox="1">
-            <a:spLocks/>
-          </p:cNvSpPr>
-          <p:nvPr/>
-        </p:nvSpPr>
-        <p:spPr>
-          <a:xfrm>
-            <a:off x="3163126" y="21890"/>
-            <a:ext cx="1365661" cy="343235"/>
-          </a:xfrm>
-          <a:prstGeom prst="rect">
-            <a:avLst/>
-          </a:prstGeom>
-        </p:spPr>
-        <p:txBody>
-          <a:bodyPr vert="horz" wrap="square" lIns="91440" tIns="45720" rIns="91440" bIns="45720" rtlCol="0">
-            <a:spAutoFit/>
-          </a:bodyPr>
-          <a:lstStyle>
-            <a:lvl1pPr marL="228600" indent="-228600" algn="l" defTabSz="914400" rtl="0" eaLnBrk="1" latinLnBrk="0" hangingPunct="1">
-              <a:lnSpc>
-                <a:spcPct val="90000"/>
-              </a:lnSpc>
-              <a:spcBef>
-                <a:spcPts val="1000"/>
-              </a:spcBef>
-              <a:buFont typeface="Arial" panose="020B0604020202020204" pitchFamily="34" charset="0"/>
-              <a:buChar char="•"/>
-              <a:defRPr sz="2800" kern="1200">
-                <a:solidFill>
-                  <a:schemeClr val="tx1"/>
-                </a:solidFill>
-                <a:latin typeface="+mn-lt"/>
-                <a:ea typeface="+mn-ea"/>
-                <a:cs typeface="+mn-cs"/>
-              </a:defRPr>
-            </a:lvl1pPr>
-            <a:lvl2pPr marL="685800" indent="-228600" algn="l" defTabSz="914400" rtl="0" eaLnBrk="1" latinLnBrk="0" hangingPunct="1">
-              <a:lnSpc>
-                <a:spcPct val="90000"/>
-              </a:lnSpc>
-              <a:spcBef>
-                <a:spcPts val="500"/>
-              </a:spcBef>
-              <a:buFont typeface="Arial" panose="020B0604020202020204" pitchFamily="34" charset="0"/>
-              <a:buChar char="•"/>
-              <a:defRPr sz="2400" kern="1200">
-                <a:solidFill>
-                  <a:schemeClr val="tx1"/>
-                </a:solidFill>
-                <a:latin typeface="+mn-lt"/>
-                <a:ea typeface="+mn-ea"/>
-                <a:cs typeface="+mn-cs"/>
-              </a:defRPr>
-            </a:lvl2pPr>
-            <a:lvl3pPr marL="1143000" indent="-228600" algn="l" defTabSz="914400" rtl="0" eaLnBrk="1" latinLnBrk="0" hangingPunct="1">
-              <a:lnSpc>
-                <a:spcPct val="90000"/>
-              </a:lnSpc>
-              <a:spcBef>
-                <a:spcPts val="500"/>
-              </a:spcBef>
-              <a:buFont typeface="Arial" panose="020B0604020202020204" pitchFamily="34" charset="0"/>
-              <a:buChar char="•"/>
-              <a:defRPr sz="2000" kern="1200">
-                <a:solidFill>
-                  <a:schemeClr val="tx1"/>
-                </a:solidFill>
-                <a:latin typeface="+mn-lt"/>
-                <a:ea typeface="+mn-ea"/>
-                <a:cs typeface="+mn-cs"/>
-              </a:defRPr>
-            </a:lvl3pPr>
-            <a:lvl4pPr marL="1600200" indent="-228600" algn="l" defTabSz="914400" rtl="0" eaLnBrk="1" latinLnBrk="0" hangingPunct="1">
-              <a:lnSpc>
-                <a:spcPct val="90000"/>
-              </a:lnSpc>
-              <a:spcBef>
-                <a:spcPts val="500"/>
-              </a:spcBef>
-              <a:buFont typeface="Arial" panose="020B0604020202020204" pitchFamily="34" charset="0"/>
-              <a:buChar char="•"/>
-              <a:defRPr sz="1800" kern="1200">
-                <a:solidFill>
-                  <a:schemeClr val="tx1"/>
-                </a:solidFill>
-                <a:latin typeface="+mn-lt"/>
-                <a:ea typeface="+mn-ea"/>
-                <a:cs typeface="+mn-cs"/>
-              </a:defRPr>
-            </a:lvl4pPr>
-            <a:lvl5pPr marL="2057400" indent="-228600" algn="l" defTabSz="914400" rtl="0" eaLnBrk="1" latinLnBrk="0" hangingPunct="1">
-              <a:lnSpc>
-                <a:spcPct val="90000"/>
-              </a:lnSpc>
-              <a:spcBef>
-                <a:spcPts val="500"/>
-              </a:spcBef>
-              <a:buFont typeface="Arial" panose="020B0604020202020204" pitchFamily="34" charset="0"/>
-              <a:buChar char="•"/>
-              <a:defRPr sz="1800" kern="1200">
-                <a:solidFill>
-                  <a:schemeClr val="tx1"/>
-                </a:solidFill>
-                <a:latin typeface="+mn-lt"/>
-                <a:ea typeface="+mn-ea"/>
-                <a:cs typeface="+mn-cs"/>
-              </a:defRPr>
-            </a:lvl5pPr>
-            <a:lvl6pPr marL="2514600" indent="-228600" algn="l" defTabSz="914400" rtl="0" eaLnBrk="1" latinLnBrk="0" hangingPunct="1">
-              <a:lnSpc>
-                <a:spcPct val="90000"/>
-              </a:lnSpc>
-              <a:spcBef>
-                <a:spcPts val="500"/>
-              </a:spcBef>
-              <a:buFont typeface="Arial" panose="020B0604020202020204" pitchFamily="34" charset="0"/>
-              <a:buChar char="•"/>
-              <a:defRPr sz="1800" kern="1200">
-                <a:solidFill>
-                  <a:schemeClr val="tx1"/>
-                </a:solidFill>
-                <a:latin typeface="+mn-lt"/>
-                <a:ea typeface="+mn-ea"/>
-                <a:cs typeface="+mn-cs"/>
-              </a:defRPr>
-            </a:lvl6pPr>
-            <a:lvl7pPr marL="2971800" indent="-228600" algn="l" defTabSz="914400" rtl="0" eaLnBrk="1" latinLnBrk="0" hangingPunct="1">
-              <a:lnSpc>
-                <a:spcPct val="90000"/>
-              </a:lnSpc>
-              <a:spcBef>
-                <a:spcPts val="500"/>
-              </a:spcBef>
-              <a:buFont typeface="Arial" panose="020B0604020202020204" pitchFamily="34" charset="0"/>
-              <a:buChar char="•"/>
-              <a:defRPr sz="1800" kern="1200">
-                <a:solidFill>
-                  <a:schemeClr val="tx1"/>
-                </a:solidFill>
-                <a:latin typeface="+mn-lt"/>
-                <a:ea typeface="+mn-ea"/>
-                <a:cs typeface="+mn-cs"/>
-              </a:defRPr>
-            </a:lvl7pPr>
-            <a:lvl8pPr marL="3429000" indent="-228600" algn="l" defTabSz="914400" rtl="0" eaLnBrk="1" latinLnBrk="0" hangingPunct="1">
-              <a:lnSpc>
-                <a:spcPct val="90000"/>
-              </a:lnSpc>
-              <a:spcBef>
-                <a:spcPts val="500"/>
-              </a:spcBef>
-              <a:buFont typeface="Arial" panose="020B0604020202020204" pitchFamily="34" charset="0"/>
-              <a:buChar char="•"/>
-              <a:defRPr sz="1800" kern="1200">
-                <a:solidFill>
-                  <a:schemeClr val="tx1"/>
-                </a:solidFill>
-                <a:latin typeface="+mn-lt"/>
-                <a:ea typeface="+mn-ea"/>
-                <a:cs typeface="+mn-cs"/>
-              </a:defRPr>
-            </a:lvl8pPr>
-            <a:lvl9pPr marL="3886200" indent="-228600" algn="l" defTabSz="914400" rtl="0" eaLnBrk="1" latinLnBrk="0" hangingPunct="1">
-              <a:lnSpc>
-                <a:spcPct val="90000"/>
-              </a:lnSpc>
-              <a:spcBef>
-                <a:spcPts val="500"/>
-              </a:spcBef>
-              <a:buFont typeface="Arial" panose="020B0604020202020204" pitchFamily="34" charset="0"/>
-              <a:buChar char="•"/>
-              <a:defRPr sz="1800" kern="1200">
-                <a:solidFill>
-                  <a:schemeClr val="tx1"/>
-                </a:solidFill>
-                <a:latin typeface="+mn-lt"/>
-                <a:ea typeface="+mn-ea"/>
-                <a:cs typeface="+mn-cs"/>
-              </a:defRPr>
-            </a:lvl9pPr>
-          </a:lstStyle>
-          <a:p>
-            <a:pPr marL="0" indent="0">
-              <a:buNone/>
-            </a:pPr>
-            <a:r>
-              <a:rPr lang="en-NL" sz="1800" b="1" dirty="0"/>
-              <a:t>October</a:t>
-            </a:r>
-            <a:endParaRPr lang="en-NL" sz="1800" i="1" dirty="0"/>
-          </a:p>
-        </p:txBody>
-      </p:sp>
     </p:spTree>
     <p:extLst>
       <p:ext uri="{BB962C8B-B14F-4D97-AF65-F5344CB8AC3E}">
-        <p14:creationId xmlns:p14="http://schemas.microsoft.com/office/powerpoint/2010/main" val="2817248769"/>
+        <p14:creationId xmlns:p14="http://schemas.microsoft.com/office/powerpoint/2010/main" val="2017025619"/>
       </p:ext>
     </p:extLst>
   </p:cSld>
@@ -14848,47 +13580,85 @@
         </p:nvSpPr>
         <p:spPr/>
         <p:txBody>
-          <a:bodyPr/>
+          <a:bodyPr>
+            <a:normAutofit lnSpcReduction="10000"/>
+          </a:bodyPr>
           <a:lstStyle/>
           <a:p>
-            <a:r>
-              <a:rPr lang="en-NL" dirty="0"/>
+            <a:pPr>
+              <a:lnSpc>
+                <a:spcPct val="150000"/>
+              </a:lnSpc>
+            </a:pPr>
+            <a:r>
+              <a:rPr lang="en-NL" sz="2400" dirty="0"/>
               <a:t>The grade is an average of the two assignments you hand in on Canvas.</a:t>
             </a:r>
           </a:p>
           <a:p>
-            <a:r>
-              <a:rPr lang="en-NL" dirty="0"/>
-              <a:t>Both need to be</a:t>
-            </a:r>
-            <a:r>
-              <a:rPr lang="en-NL" b="1" dirty="0"/>
+            <a:pPr>
+              <a:lnSpc>
+                <a:spcPct val="150000"/>
+              </a:lnSpc>
+            </a:pPr>
+            <a:r>
+              <a:rPr lang="en-NL" sz="2400" dirty="0"/>
+              <a:t>You work in pairs; different pair in each assignment. </a:t>
+            </a:r>
+          </a:p>
+          <a:p>
+            <a:pPr>
+              <a:lnSpc>
+                <a:spcPct val="150000"/>
+              </a:lnSpc>
+            </a:pPr>
+            <a:r>
+              <a:rPr lang="en-NL" sz="2400" dirty="0"/>
+              <a:t>Both assignments need to be</a:t>
+            </a:r>
+            <a:r>
+              <a:rPr lang="en-NL" sz="2400" b="1" dirty="0"/>
               <a:t> at least 5.5 to pass</a:t>
             </a:r>
           </a:p>
           <a:p>
-            <a:r>
-              <a:rPr lang="en-NL" dirty="0"/>
+            <a:pPr>
+              <a:lnSpc>
+                <a:spcPct val="150000"/>
+              </a:lnSpc>
+            </a:pPr>
+            <a:r>
+              <a:rPr lang="en-NL" sz="2400" dirty="0"/>
               <a:t>You need to </a:t>
             </a:r>
             <a:r>
-              <a:rPr lang="en-NL" b="1" dirty="0"/>
+              <a:rPr lang="en-NL" sz="2400" b="1" dirty="0"/>
               <a:t>pass </a:t>
             </a:r>
             <a:r>
-              <a:rPr lang="en-NL" dirty="0"/>
+              <a:rPr lang="en-NL" sz="2400" dirty="0"/>
               <a:t>the mini oral test</a:t>
             </a:r>
           </a:p>
           <a:p>
-            <a:r>
-              <a:rPr lang="en-NL" dirty="0"/>
+            <a:pPr>
+              <a:lnSpc>
+                <a:spcPct val="150000"/>
+              </a:lnSpc>
+            </a:pPr>
+            <a:r>
+              <a:rPr lang="en-NL" sz="2400" dirty="0"/>
               <a:t>You need to be present at all tutorials to get a grade</a:t>
             </a:r>
           </a:p>
           <a:p>
-            <a:r>
-              <a:rPr lang="en-NL" dirty="0"/>
+            <a:pPr>
+              <a:lnSpc>
+                <a:spcPct val="150000"/>
+              </a:lnSpc>
+            </a:pPr>
+            <a:r>
+              <a:rPr lang="en-NL" sz="2400" dirty="0"/>
               <a:t>Resits are only possible in emergency situations; make an appointment with the respective teacher. </a:t>
             </a:r>
           </a:p>

</xml_diff>

<commit_message>
update MDA pitch slides just before pitch moment
</commit_message>
<xml_diff>
--- a/lectures/0_course_introduction.pptx
+++ b/lectures/0_course_introduction.pptx
@@ -279,7 +279,7 @@
           <a:p>
             <a:fld id="{7315D9CD-A6C7-AE4E-875B-351995A2D2A0}" type="datetimeFigureOut">
               <a:rPr lang="en-NL" smtClean="0"/>
-              <a:t>02/09/2026</a:t>
+              <a:t>14/09/2026</a:t>
             </a:fld>
             <a:endParaRPr lang="en-NL"/>
           </a:p>
@@ -479,7 +479,7 @@
           <a:p>
             <a:fld id="{7315D9CD-A6C7-AE4E-875B-351995A2D2A0}" type="datetimeFigureOut">
               <a:rPr lang="en-NL" smtClean="0"/>
-              <a:t>02/09/2026</a:t>
+              <a:t>14/09/2026</a:t>
             </a:fld>
             <a:endParaRPr lang="en-NL"/>
           </a:p>
@@ -689,7 +689,7 @@
           <a:p>
             <a:fld id="{7315D9CD-A6C7-AE4E-875B-351995A2D2A0}" type="datetimeFigureOut">
               <a:rPr lang="en-NL" smtClean="0"/>
-              <a:t>02/09/2026</a:t>
+              <a:t>14/09/2026</a:t>
             </a:fld>
             <a:endParaRPr lang="en-NL"/>
           </a:p>
@@ -889,7 +889,7 @@
           <a:p>
             <a:fld id="{7315D9CD-A6C7-AE4E-875B-351995A2D2A0}" type="datetimeFigureOut">
               <a:rPr lang="en-NL" smtClean="0"/>
-              <a:t>02/09/2026</a:t>
+              <a:t>14/09/2026</a:t>
             </a:fld>
             <a:endParaRPr lang="en-NL"/>
           </a:p>
@@ -1165,7 +1165,7 @@
           <a:p>
             <a:fld id="{7315D9CD-A6C7-AE4E-875B-351995A2D2A0}" type="datetimeFigureOut">
               <a:rPr lang="en-NL" smtClean="0"/>
-              <a:t>02/09/2026</a:t>
+              <a:t>14/09/2026</a:t>
             </a:fld>
             <a:endParaRPr lang="en-NL"/>
           </a:p>
@@ -1433,7 +1433,7 @@
           <a:p>
             <a:fld id="{7315D9CD-A6C7-AE4E-875B-351995A2D2A0}" type="datetimeFigureOut">
               <a:rPr lang="en-NL" smtClean="0"/>
-              <a:t>02/09/2026</a:t>
+              <a:t>14/09/2026</a:t>
             </a:fld>
             <a:endParaRPr lang="en-NL"/>
           </a:p>
@@ -1848,7 +1848,7 @@
           <a:p>
             <a:fld id="{7315D9CD-A6C7-AE4E-875B-351995A2D2A0}" type="datetimeFigureOut">
               <a:rPr lang="en-NL" smtClean="0"/>
-              <a:t>02/09/2026</a:t>
+              <a:t>14/09/2026</a:t>
             </a:fld>
             <a:endParaRPr lang="en-NL"/>
           </a:p>
@@ -1990,7 +1990,7 @@
           <a:p>
             <a:fld id="{7315D9CD-A6C7-AE4E-875B-351995A2D2A0}" type="datetimeFigureOut">
               <a:rPr lang="en-NL" smtClean="0"/>
-              <a:t>02/09/2026</a:t>
+              <a:t>14/09/2026</a:t>
             </a:fld>
             <a:endParaRPr lang="en-NL"/>
           </a:p>
@@ -2103,7 +2103,7 @@
           <a:p>
             <a:fld id="{7315D9CD-A6C7-AE4E-875B-351995A2D2A0}" type="datetimeFigureOut">
               <a:rPr lang="en-NL" smtClean="0"/>
-              <a:t>02/09/2026</a:t>
+              <a:t>14/09/2026</a:t>
             </a:fld>
             <a:endParaRPr lang="en-NL"/>
           </a:p>
@@ -2416,7 +2416,7 @@
           <a:p>
             <a:fld id="{7315D9CD-A6C7-AE4E-875B-351995A2D2A0}" type="datetimeFigureOut">
               <a:rPr lang="en-NL" smtClean="0"/>
-              <a:t>02/09/2026</a:t>
+              <a:t>14/09/2026</a:t>
             </a:fld>
             <a:endParaRPr lang="en-NL"/>
           </a:p>
@@ -2705,7 +2705,7 @@
           <a:p>
             <a:fld id="{7315D9CD-A6C7-AE4E-875B-351995A2D2A0}" type="datetimeFigureOut">
               <a:rPr lang="en-NL" smtClean="0"/>
-              <a:t>02/09/2026</a:t>
+              <a:t>14/09/2026</a:t>
             </a:fld>
             <a:endParaRPr lang="en-NL"/>
           </a:p>
@@ -2948,7 +2948,7 @@
           <a:p>
             <a:fld id="{7315D9CD-A6C7-AE4E-875B-351995A2D2A0}" type="datetimeFigureOut">
               <a:rPr lang="en-NL" smtClean="0"/>
-              <a:t>02/09/2026</a:t>
+              <a:t>14/09/2026</a:t>
             </a:fld>
             <a:endParaRPr lang="en-NL"/>
           </a:p>
@@ -10313,7 +10313,9 @@
         </p:nvSpPr>
         <p:spPr/>
         <p:txBody>
-          <a:bodyPr/>
+          <a:bodyPr>
+            <a:normAutofit fontScale="85000" lnSpcReduction="20000"/>
+          </a:bodyPr>
           <a:lstStyle/>
           <a:p>
             <a:pPr>
@@ -10354,7 +10356,31 @@
             </a:r>
             <a:r>
               <a:rPr lang="en-NL" dirty="0"/>
-              <a:t>allowed to use genAI to replace your work and critical thinking, and to generate full solutions to assignment. .</a:t>
+              <a:t>allowed to use genAI to replace your work and critical thinking, and to generate full solutions to assignment. </a:t>
+            </a:r>
+          </a:p>
+          <a:p>
+            <a:pPr marL="0" indent="0">
+              <a:buNone/>
+            </a:pPr>
+            <a:endParaRPr lang="en-NL" dirty="0"/>
+          </a:p>
+          <a:p>
+            <a:pPr marL="0" indent="0">
+              <a:lnSpc>
+                <a:spcPct val="160000"/>
+              </a:lnSpc>
+              <a:buNone/>
+            </a:pPr>
+            <a:r>
+              <a:rPr lang="en-NL" i="1" dirty="0">
+                <a:solidFill>
+                  <a:schemeClr val="bg1">
+                    <a:lumMod val="65000"/>
+                  </a:schemeClr>
+                </a:solidFill>
+              </a:rPr>
+              <a:t>“If we view assignments as a critical tool for learning, both the instructor and the student need to invest their own thoughts and efforts in the process.” (MIT AI and Education report, august 2026)</a:t>
             </a:r>
           </a:p>
         </p:txBody>

</xml_diff>

<commit_message>
update learning goals in slides
</commit_message>
<xml_diff>
--- a/lectures/0_course_introduction.pptx
+++ b/lectures/0_course_introduction.pptx
@@ -24,6 +24,7 @@
     <p:sldId id="997" r:id="rId18"/>
     <p:sldId id="1003" r:id="rId19"/>
     <p:sldId id="1001" r:id="rId20"/>
+    <p:sldId id="1008" r:id="rId21"/>
   </p:sldIdLst>
   <p:sldSz cx="12192000" cy="6858000"/>
   <p:notesSz cx="6858000" cy="9144000"/>
@@ -279,7 +280,7 @@
           <a:p>
             <a:fld id="{7315D9CD-A6C7-AE4E-875B-351995A2D2A0}" type="datetimeFigureOut">
               <a:rPr lang="en-NL" smtClean="0"/>
-              <a:t>14/09/2026</a:t>
+              <a:t>25/09/2026</a:t>
             </a:fld>
             <a:endParaRPr lang="en-NL"/>
           </a:p>
@@ -479,7 +480,7 @@
           <a:p>
             <a:fld id="{7315D9CD-A6C7-AE4E-875B-351995A2D2A0}" type="datetimeFigureOut">
               <a:rPr lang="en-NL" smtClean="0"/>
-              <a:t>14/09/2026</a:t>
+              <a:t>25/09/2026</a:t>
             </a:fld>
             <a:endParaRPr lang="en-NL"/>
           </a:p>
@@ -689,7 +690,7 @@
           <a:p>
             <a:fld id="{7315D9CD-A6C7-AE4E-875B-351995A2D2A0}" type="datetimeFigureOut">
               <a:rPr lang="en-NL" smtClean="0"/>
-              <a:t>14/09/2026</a:t>
+              <a:t>25/09/2026</a:t>
             </a:fld>
             <a:endParaRPr lang="en-NL"/>
           </a:p>
@@ -889,7 +890,7 @@
           <a:p>
             <a:fld id="{7315D9CD-A6C7-AE4E-875B-351995A2D2A0}" type="datetimeFigureOut">
               <a:rPr lang="en-NL" smtClean="0"/>
-              <a:t>14/09/2026</a:t>
+              <a:t>25/09/2026</a:t>
             </a:fld>
             <a:endParaRPr lang="en-NL"/>
           </a:p>
@@ -1165,7 +1166,7 @@
           <a:p>
             <a:fld id="{7315D9CD-A6C7-AE4E-875B-351995A2D2A0}" type="datetimeFigureOut">
               <a:rPr lang="en-NL" smtClean="0"/>
-              <a:t>14/09/2026</a:t>
+              <a:t>25/09/2026</a:t>
             </a:fld>
             <a:endParaRPr lang="en-NL"/>
           </a:p>
@@ -1433,7 +1434,7 @@
           <a:p>
             <a:fld id="{7315D9CD-A6C7-AE4E-875B-351995A2D2A0}" type="datetimeFigureOut">
               <a:rPr lang="en-NL" smtClean="0"/>
-              <a:t>14/09/2026</a:t>
+              <a:t>25/09/2026</a:t>
             </a:fld>
             <a:endParaRPr lang="en-NL"/>
           </a:p>
@@ -1848,7 +1849,7 @@
           <a:p>
             <a:fld id="{7315D9CD-A6C7-AE4E-875B-351995A2D2A0}" type="datetimeFigureOut">
               <a:rPr lang="en-NL" smtClean="0"/>
-              <a:t>14/09/2026</a:t>
+              <a:t>25/09/2026</a:t>
             </a:fld>
             <a:endParaRPr lang="en-NL"/>
           </a:p>
@@ -1990,7 +1991,7 @@
           <a:p>
             <a:fld id="{7315D9CD-A6C7-AE4E-875B-351995A2D2A0}" type="datetimeFigureOut">
               <a:rPr lang="en-NL" smtClean="0"/>
-              <a:t>14/09/2026</a:t>
+              <a:t>25/09/2026</a:t>
             </a:fld>
             <a:endParaRPr lang="en-NL"/>
           </a:p>
@@ -2103,7 +2104,7 @@
           <a:p>
             <a:fld id="{7315D9CD-A6C7-AE4E-875B-351995A2D2A0}" type="datetimeFigureOut">
               <a:rPr lang="en-NL" smtClean="0"/>
-              <a:t>14/09/2026</a:t>
+              <a:t>25/09/2026</a:t>
             </a:fld>
             <a:endParaRPr lang="en-NL"/>
           </a:p>
@@ -2416,7 +2417,7 @@
           <a:p>
             <a:fld id="{7315D9CD-A6C7-AE4E-875B-351995A2D2A0}" type="datetimeFigureOut">
               <a:rPr lang="en-NL" smtClean="0"/>
-              <a:t>14/09/2026</a:t>
+              <a:t>25/09/2026</a:t>
             </a:fld>
             <a:endParaRPr lang="en-NL"/>
           </a:p>
@@ -2705,7 +2706,7 @@
           <a:p>
             <a:fld id="{7315D9CD-A6C7-AE4E-875B-351995A2D2A0}" type="datetimeFigureOut">
               <a:rPr lang="en-NL" smtClean="0"/>
-              <a:t>14/09/2026</a:t>
+              <a:t>25/09/2026</a:t>
             </a:fld>
             <a:endParaRPr lang="en-NL"/>
           </a:p>
@@ -2948,7 +2949,7 @@
           <a:p>
             <a:fld id="{7315D9CD-A6C7-AE4E-875B-351995A2D2A0}" type="datetimeFigureOut">
               <a:rPr lang="en-NL" smtClean="0"/>
-              <a:t>14/09/2026</a:t>
+              <a:t>25/09/2026</a:t>
             </a:fld>
             <a:endParaRPr lang="en-NL"/>
           </a:p>
@@ -10736,6 +10737,91 @@
 </p:sld>
 </file>
 
+<file path=ppt/slides/slide20.xml><?xml version="1.0" encoding="utf-8"?>
+<p:sld xmlns:a="http://schemas.openxmlformats.org/drawingml/2006/main" xmlns:r="http://schemas.openxmlformats.org/officeDocument/2006/relationships" xmlns:p="http://schemas.openxmlformats.org/presentationml/2006/main">
+  <p:cSld>
+    <p:spTree>
+      <p:nvGrpSpPr>
+        <p:cNvPr id="1" name=""/>
+        <p:cNvGrpSpPr/>
+        <p:nvPr/>
+      </p:nvGrpSpPr>
+      <p:grpSpPr>
+        <a:xfrm>
+          <a:off x="0" y="0"/>
+          <a:ext cx="0" cy="0"/>
+          <a:chOff x="0" y="0"/>
+          <a:chExt cx="0" cy="0"/>
+        </a:xfrm>
+      </p:grpSpPr>
+      <p:sp>
+        <p:nvSpPr>
+          <p:cNvPr id="2" name="Title 1">
+            <a:extLst>
+              <a:ext uri="{FF2B5EF4-FFF2-40B4-BE49-F238E27FC236}">
+                <a16:creationId xmlns:a16="http://schemas.microsoft.com/office/drawing/2014/main" id="{A15E234B-5EEF-DD97-C419-4A1326116408}"/>
+              </a:ext>
+            </a:extLst>
+          </p:cNvPr>
+          <p:cNvSpPr>
+            <a:spLocks noGrp="1"/>
+          </p:cNvSpPr>
+          <p:nvPr>
+            <p:ph type="title"/>
+          </p:nvPr>
+        </p:nvSpPr>
+        <p:spPr/>
+        <p:txBody>
+          <a:bodyPr/>
+          <a:lstStyle/>
+          <a:p>
+            <a:endParaRPr lang="en-NL"/>
+          </a:p>
+        </p:txBody>
+      </p:sp>
+      <p:pic>
+        <p:nvPicPr>
+          <p:cNvPr id="4" name="Picture 3">
+            <a:extLst>
+              <a:ext uri="{FF2B5EF4-FFF2-40B4-BE49-F238E27FC236}">
+                <a16:creationId xmlns:a16="http://schemas.microsoft.com/office/drawing/2014/main" id="{FAF095F2-61B3-F9DC-767C-CAF1897E6945}"/>
+              </a:ext>
+            </a:extLst>
+          </p:cNvPr>
+          <p:cNvPicPr>
+            <a:picLocks noChangeAspect="1"/>
+          </p:cNvPicPr>
+          <p:nvPr/>
+        </p:nvPicPr>
+        <p:blipFill>
+          <a:blip r:embed="rId2"/>
+          <a:stretch>
+            <a:fillRect/>
+          </a:stretch>
+        </p:blipFill>
+        <p:spPr>
+          <a:xfrm>
+            <a:off x="341957" y="1631950"/>
+            <a:ext cx="11240443" cy="3314700"/>
+          </a:xfrm>
+          <a:prstGeom prst="rect">
+            <a:avLst/>
+          </a:prstGeom>
+        </p:spPr>
+      </p:pic>
+    </p:spTree>
+    <p:extLst>
+      <p:ext uri="{BB962C8B-B14F-4D97-AF65-F5344CB8AC3E}">
+        <p14:creationId xmlns:p14="http://schemas.microsoft.com/office/powerpoint/2010/main" val="2075720287"/>
+      </p:ext>
+    </p:extLst>
+  </p:cSld>
+  <p:clrMapOvr>
+    <a:masterClrMapping/>
+  </p:clrMapOvr>
+</p:sld>
+</file>
+
 <file path=ppt/slides/slide3.xml><?xml version="1.0" encoding="utf-8"?>
 <p:sld xmlns:a="http://schemas.openxmlformats.org/drawingml/2006/main" xmlns:r="http://schemas.openxmlformats.org/officeDocument/2006/relationships" xmlns:p="http://schemas.openxmlformats.org/presentationml/2006/main">
   <p:cSld>

</xml_diff>

<commit_message>
mini edit course intro slides
</commit_message>
<xml_diff>
--- a/lectures/0_course_introduction.pptx
+++ b/lectures/0_course_introduction.pptx
@@ -280,7 +280,7 @@
           <a:p>
             <a:fld id="{7315D9CD-A6C7-AE4E-875B-351995A2D2A0}" type="datetimeFigureOut">
               <a:rPr lang="en-NL" smtClean="0"/>
-              <a:t>25/09/2026</a:t>
+              <a:t>28/09/2026</a:t>
             </a:fld>
             <a:endParaRPr lang="en-NL"/>
           </a:p>
@@ -480,7 +480,7 @@
           <a:p>
             <a:fld id="{7315D9CD-A6C7-AE4E-875B-351995A2D2A0}" type="datetimeFigureOut">
               <a:rPr lang="en-NL" smtClean="0"/>
-              <a:t>25/09/2026</a:t>
+              <a:t>28/09/2026</a:t>
             </a:fld>
             <a:endParaRPr lang="en-NL"/>
           </a:p>
@@ -690,7 +690,7 @@
           <a:p>
             <a:fld id="{7315D9CD-A6C7-AE4E-875B-351995A2D2A0}" type="datetimeFigureOut">
               <a:rPr lang="en-NL" smtClean="0"/>
-              <a:t>25/09/2026</a:t>
+              <a:t>28/09/2026</a:t>
             </a:fld>
             <a:endParaRPr lang="en-NL"/>
           </a:p>
@@ -890,7 +890,7 @@
           <a:p>
             <a:fld id="{7315D9CD-A6C7-AE4E-875B-351995A2D2A0}" type="datetimeFigureOut">
               <a:rPr lang="en-NL" smtClean="0"/>
-              <a:t>25/09/2026</a:t>
+              <a:t>28/09/2026</a:t>
             </a:fld>
             <a:endParaRPr lang="en-NL"/>
           </a:p>
@@ -1166,7 +1166,7 @@
           <a:p>
             <a:fld id="{7315D9CD-A6C7-AE4E-875B-351995A2D2A0}" type="datetimeFigureOut">
               <a:rPr lang="en-NL" smtClean="0"/>
-              <a:t>25/09/2026</a:t>
+              <a:t>28/09/2026</a:t>
             </a:fld>
             <a:endParaRPr lang="en-NL"/>
           </a:p>
@@ -1434,7 +1434,7 @@
           <a:p>
             <a:fld id="{7315D9CD-A6C7-AE4E-875B-351995A2D2A0}" type="datetimeFigureOut">
               <a:rPr lang="en-NL" smtClean="0"/>
-              <a:t>25/09/2026</a:t>
+              <a:t>28/09/2026</a:t>
             </a:fld>
             <a:endParaRPr lang="en-NL"/>
           </a:p>
@@ -1849,7 +1849,7 @@
           <a:p>
             <a:fld id="{7315D9CD-A6C7-AE4E-875B-351995A2D2A0}" type="datetimeFigureOut">
               <a:rPr lang="en-NL" smtClean="0"/>
-              <a:t>25/09/2026</a:t>
+              <a:t>28/09/2026</a:t>
             </a:fld>
             <a:endParaRPr lang="en-NL"/>
           </a:p>
@@ -1991,7 +1991,7 @@
           <a:p>
             <a:fld id="{7315D9CD-A6C7-AE4E-875B-351995A2D2A0}" type="datetimeFigureOut">
               <a:rPr lang="en-NL" smtClean="0"/>
-              <a:t>25/09/2026</a:t>
+              <a:t>28/09/2026</a:t>
             </a:fld>
             <a:endParaRPr lang="en-NL"/>
           </a:p>
@@ -2104,7 +2104,7 @@
           <a:p>
             <a:fld id="{7315D9CD-A6C7-AE4E-875B-351995A2D2A0}" type="datetimeFigureOut">
               <a:rPr lang="en-NL" smtClean="0"/>
-              <a:t>25/09/2026</a:t>
+              <a:t>28/09/2026</a:t>
             </a:fld>
             <a:endParaRPr lang="en-NL"/>
           </a:p>
@@ -2417,7 +2417,7 @@
           <a:p>
             <a:fld id="{7315D9CD-A6C7-AE4E-875B-351995A2D2A0}" type="datetimeFigureOut">
               <a:rPr lang="en-NL" smtClean="0"/>
-              <a:t>25/09/2026</a:t>
+              <a:t>28/09/2026</a:t>
             </a:fld>
             <a:endParaRPr lang="en-NL"/>
           </a:p>
@@ -2706,7 +2706,7 @@
           <a:p>
             <a:fld id="{7315D9CD-A6C7-AE4E-875B-351995A2D2A0}" type="datetimeFigureOut">
               <a:rPr lang="en-NL" smtClean="0"/>
-              <a:t>25/09/2026</a:t>
+              <a:t>28/09/2026</a:t>
             </a:fld>
             <a:endParaRPr lang="en-NL"/>
           </a:p>
@@ -2949,7 +2949,7 @@
           <a:p>
             <a:fld id="{7315D9CD-A6C7-AE4E-875B-351995A2D2A0}" type="datetimeFigureOut">
               <a:rPr lang="en-NL" smtClean="0"/>
-              <a:t>25/09/2026</a:t>
+              <a:t>28/09/2026</a:t>
             </a:fld>
             <a:endParaRPr lang="en-NL"/>
           </a:p>
@@ -6835,55 +6835,6 @@
           </p:txBody>
         </p:sp>
       </p:grpSp>
-      <p:pic>
-        <p:nvPicPr>
-          <p:cNvPr id="4" name="Picture 2">
-            <a:extLst>
-              <a:ext uri="{FF2B5EF4-FFF2-40B4-BE49-F238E27FC236}">
-                <a16:creationId xmlns:a16="http://schemas.microsoft.com/office/drawing/2014/main" id="{B124EEF2-10CB-1AD7-FBCA-7C491B690EE8}"/>
-              </a:ext>
-            </a:extLst>
-          </p:cNvPr>
-          <p:cNvPicPr>
-            <a:picLocks noChangeAspect="1" noChangeArrowheads="1"/>
-          </p:cNvPicPr>
-          <p:nvPr/>
-        </p:nvPicPr>
-        <p:blipFill>
-          <a:blip r:embed="rId2">
-            <a:extLst>
-              <a:ext uri="{28A0092B-C50C-407E-A947-70E740481C1C}">
-                <a14:useLocalDpi xmlns:a14="http://schemas.microsoft.com/office/drawing/2010/main" val="0"/>
-              </a:ext>
-            </a:extLst>
-          </a:blip>
-          <a:stretch>
-            <a:fillRect/>
-          </a:stretch>
-        </p:blipFill>
-        <p:spPr bwMode="auto">
-          <a:xfrm>
-            <a:off x="7203089" y="1338417"/>
-            <a:ext cx="4507994" cy="4181164"/>
-          </a:xfrm>
-          <a:prstGeom prst="rect">
-            <a:avLst/>
-          </a:prstGeom>
-          <a:noFill/>
-          <a:ln>
-            <a:noFill/>
-          </a:ln>
-          <a:extLst>
-            <a:ext uri="{909E8E84-426E-40DD-AFC4-6F175D3DCCD1}">
-              <a14:hiddenFill xmlns:a14="http://schemas.microsoft.com/office/drawing/2010/main">
-                <a:solidFill>
-                  <a:srgbClr val="FFFFFF"/>
-                </a:solidFill>
-              </a14:hiddenFill>
-            </a:ext>
-          </a:extLst>
-        </p:spPr>
-      </p:pic>
     </p:spTree>
     <p:extLst>
       <p:ext uri="{BB962C8B-B14F-4D97-AF65-F5344CB8AC3E}">

</xml_diff>